<commit_message>
Deck rebuilt against the final build (15 slides)
- new "Chain of custody" slide: the identity problem and the hash chain,
  stated with its limit (detectable, not impossible) and handing off to the
  anchoring slide that closes that gap
- ingest step now describes what it actually does - parses and merges an
  uploaded CSV into the case graph, rather than only hashing it
- evidence slide carries the final verified figures: 2 chains, hash-chained
  custody, 183 tests, 19 endpoints, 4,582 lines
- closing slide carries the repository URL

Validated and rendered through PowerPoint.

Co-Authored-By: Claude Opus 5 <noreply@anthropic.com>
</commit_message>
<xml_diff>
--- a/Violet_Milk_Deck_2026.pptx
+++ b/Violet_Milk_Deck_2026.pptx
@@ -19,9 +19,10 @@
     <p:sldId id="267" r:id="rId13"/>
     <p:sldId id="268" r:id="rId14"/>
     <p:sldId id="269" r:id="rId15"/>
+    <p:sldId id="270" r:id="rId16"/>
   </p:sldIdLst>
   <p:notesMasterIdLst>
-    <p:notesMasterId r:id="rId16"/>
+    <p:notesMasterId r:id="rId17"/>
   </p:notesMasterIdLst>
   <p:sldSz cx="12192000" cy="6858000"/>
   <p:notesSz cx="6858000" cy="12192000"/>
@@ -603,7 +604,7 @@
           <a:p>
             <a:r>
               <a:rPr lang="en-US" dirty="0"/>
-              <a:t>If offered a random address, trace it. If it fails, say why: bounds, or no token activity. Do not pretend.</a:t>
+              <a:t>Volunteer the limits before anyone asks. An anchor is an existence-and-time proof, not an authorship proof. Saying so is what makes the rest credible - and no other team will have this at all.</a:t>
             </a:r>
             <a:endParaRPr lang="en-US" dirty="0"/>
           </a:p>
@@ -691,7 +692,7 @@
           <a:p>
             <a:r>
               <a:rPr lang="en-US" dirty="0"/>
-              <a:t>Never claim they lack multi-hop tracing - it is their core product and a judge may know it. Data sovereignty and cost are the real wins.</a:t>
+              <a:t>If offered a random address, trace it. If it fails, say why: bounds, or no token activity. Do not pretend.</a:t>
             </a:r>
             <a:endParaRPr lang="en-US" dirty="0"/>
           </a:p>
@@ -779,7 +780,7 @@
           <a:p>
             <a:r>
               <a:rPr lang="en-US" dirty="0"/>
-              <a:t>This slide creates the need for the ask. Do not claim outcomes we have not measured - one question about methodology and it collapses.</a:t>
+              <a:t>Never claim they lack multi-hop tracing - it is their core product and a judge may know it. Data sovereignty and cost are the real wins.</a:t>
             </a:r>
             <a:endParaRPr lang="en-US" dirty="0"/>
           </a:p>
@@ -867,7 +868,7 @@
           <a:p>
             <a:r>
               <a:rPr lang="en-US" dirty="0"/>
-              <a:t/>
+              <a:t>This slide creates the need for the ask. Do not claim outcomes we have not measured - one question about methodology and it collapses.</a:t>
             </a:r>
             <a:endParaRPr lang="en-US" dirty="0"/>
           </a:p>
@@ -955,7 +956,7 @@
           <a:p>
             <a:r>
               <a:rPr lang="en-US" dirty="0"/>
-              <a:t>Close on the limitation, not the boast. It is what makes the rest credible.</a:t>
+              <a:t/>
             </a:r>
             <a:endParaRPr lang="en-US" dirty="0"/>
           </a:p>
@@ -979,6 +980,94 @@
             <a:fld id="{F7021451-1387-4CA6-816F-3879F97B5CBC}" type="slidenum">
               <a:rPr lang="en-US"/>
               <a:t>14</a:t>
+            </a:fld>
+            <a:endParaRPr lang="en-US"/>
+          </a:p>
+        </p:txBody>
+      </p:sp>
+    </p:spTree>
+    <p:extLst>
+      <p:ext uri="{BB962C8B-B14F-4D97-AF65-F5344CB8AC3E}">
+        <p14:creationId xmlns:p14="http://schemas.microsoft.com/office/powerpoint/2010/main" val="1024086991"/>
+      </p:ext>
+    </p:extLst>
+  </p:cSld>
+  <p:clrMapOvr>
+    <a:masterClrMapping/>
+  </p:clrMapOvr>
+</p:notes>
+</file>
+
+<file path=ppt/notesSlides/notesSlide15.xml><?xml version="1.0" encoding="utf-8"?>
+<p:notes xmlns:a="http://schemas.openxmlformats.org/drawingml/2006/main" xmlns:r="http://schemas.openxmlformats.org/officeDocument/2006/relationships" xmlns:p="http://schemas.openxmlformats.org/presentationml/2006/main">
+  <p:cSld>
+    <p:spTree>
+      <p:nvGrpSpPr>
+        <p:cNvPr id="1" name=""/>
+        <p:cNvGrpSpPr/>
+        <p:nvPr/>
+      </p:nvGrpSpPr>
+      <p:grpSpPr>
+        <a:xfrm>
+          <a:off x="0" y="0"/>
+          <a:ext cx="0" cy="0"/>
+          <a:chOff x="0" y="0"/>
+          <a:chExt cx="0" cy="0"/>
+        </a:xfrm>
+      </p:grpSpPr>
+      <p:sp>
+        <p:nvSpPr>
+          <p:cNvPr id="2" name="Slide Image Placeholder 1"/>
+          <p:cNvSpPr>
+            <a:spLocks noGrp="1" noRot="1" noChangeAspect="1"/>
+          </p:cNvSpPr>
+          <p:nvPr>
+            <p:ph type="sldImg"/>
+          </p:nvPr>
+        </p:nvSpPr>
+        <p:spPr/>
+      </p:sp>
+      <p:sp>
+        <p:nvSpPr>
+          <p:cNvPr id="3" name="Notes Placeholder 2"/>
+          <p:cNvSpPr>
+            <a:spLocks noGrp="1"/>
+          </p:cNvSpPr>
+          <p:nvPr>
+            <p:ph type="body" idx="1"/>
+          </p:nvPr>
+        </p:nvSpPr>
+        <p:spPr/>
+        <p:txBody>
+          <a:bodyPr/>
+          <a:lstStyle/>
+          <a:p>
+            <a:r>
+              <a:rPr lang="en-US" dirty="0"/>
+              <a:t>Close on the limitation, not the boast. It is what makes the rest credible.</a:t>
+            </a:r>
+            <a:endParaRPr lang="en-US" dirty="0"/>
+          </a:p>
+        </p:txBody>
+      </p:sp>
+      <p:sp>
+        <p:nvSpPr>
+          <p:cNvPr id="4" name="Slide Number Placeholder 3"/>
+          <p:cNvSpPr>
+            <a:spLocks noGrp="1"/>
+          </p:cNvSpPr>
+          <p:nvPr>
+            <p:ph type="sldNum" sz="quarter" idx="10"/>
+          </p:nvPr>
+        </p:nvSpPr>
+        <p:spPr/>
+        <p:txBody>
+          <a:bodyPr/>
+          <a:lstStyle/>
+          <a:p>
+            <a:fld id="{F7021451-1387-4CA6-816F-3879F97B5CBC}" type="slidenum">
+              <a:rPr lang="en-US"/>
+              <a:t>15</a:t>
             </a:fld>
             <a:endParaRPr lang="en-US"/>
           </a:p>
@@ -1659,7 +1748,7 @@
           <a:p>
             <a:r>
               <a:rPr lang="en-US" dirty="0"/>
-              <a:t>Volunteer the limits before anyone asks. An anchor is an existence-and-time proof, not an authorship proof. Saying so is what makes the rest credible - and no other team will have this at all.</a:t>
+              <a:t>Say the limit out loud: detectable, not impossible. Then point at the anchoring slide, which is what closes that gap.</a:t>
             </a:r>
             <a:endParaRPr lang="en-US" dirty="0"/>
           </a:p>
@@ -2559,7 +2648,7 @@
                 <a:ea typeface="Calibri" pitchFamily="34" charset="-122"/>
                 <a:cs typeface="Calibri" pitchFamily="34" charset="-120"/>
               </a:rPr>
-              <a:t>NOT JUST OUR DATA</a:t>
+              <a:t>ANCHORED EVIDENCE</a:t>
             </a:r>
             <a:endParaRPr lang="en-US" sz="1100" dirty="0"/>
           </a:p>
@@ -2598,7 +2687,7 @@
                 <a:ea typeface="Cambria" pitchFamily="34" charset="-122"/>
                 <a:cs typeface="Cambria" pitchFamily="34" charset="-120"/>
               </a:rPr>
-              <a:t>Hand us a real address. It picks the chain itself.</a:t>
+              <a:t>We publish the digest. The proof outlives the server.</a:t>
             </a:r>
             <a:endParaRPr lang="en-US" sz="3400" dirty="0"/>
           </a:p>
@@ -2612,63 +2701,27 @@
         </p:nvSpPr>
         <p:spPr>
           <a:xfrm>
-            <a:off x="566928" y="1709928"/>
-            <a:ext cx="2743200" cy="713232"/>
-          </a:xfrm>
-          <a:prstGeom prst="rect">
-            <a:avLst/>
-          </a:prstGeom>
-          <a:noFill/>
-          <a:ln/>
-        </p:spPr>
-        <p:txBody>
-          <a:bodyPr wrap="square" lIns="0" tIns="0" rIns="0" bIns="0" rtlCol="0" anchor="ctr"/>
-          <a:lstStyle/>
-          <a:p>
-            <a:pPr indent="0" marL="0">
-              <a:buNone/>
-            </a:pPr>
-            <a:r>
-              <a:rPr lang="en-US" sz="4000" b="1" dirty="0">
-                <a:solidFill>
-                  <a:srgbClr val="8B6FD4"/>
-                </a:solidFill>
-                <a:latin typeface="Cambria" pitchFamily="34" charset="0"/>
-                <a:ea typeface="Cambria" pitchFamily="34" charset="-122"/>
-                <a:cs typeface="Cambria" pitchFamily="34" charset="-120"/>
-              </a:rPr>
-              <a:t>2</a:t>
-            </a:r>
-            <a:endParaRPr lang="en-US" sz="4000" dirty="0"/>
-          </a:p>
-        </p:txBody>
-      </p:sp>
-      <p:sp>
-        <p:nvSpPr>
-          <p:cNvPr id="5" name="Text 3"/>
-          <p:cNvSpPr txBox="1"/>
-          <p:nvPr/>
-        </p:nvSpPr>
-        <p:spPr>
-          <a:xfrm>
-            <a:off x="566928" y="2404872"/>
-            <a:ext cx="2743200" cy="237744"/>
-          </a:xfrm>
-          <a:prstGeom prst="rect">
-            <a:avLst/>
-          </a:prstGeom>
-          <a:noFill/>
-          <a:ln/>
-        </p:spPr>
-        <p:txBody>
-          <a:bodyPr wrap="square" lIns="0" tIns="0" rIns="0" bIns="0" rtlCol="0" anchor="ctr"/>
-          <a:lstStyle/>
-          <a:p>
-            <a:pPr indent="0" marL="0">
-              <a:buNone/>
-            </a:pPr>
-            <a:r>
-              <a:rPr lang="en-US" sz="1000" b="1" spc="120" kern="0" dirty="0">
+            <a:off x="566928" y="1572768"/>
+            <a:ext cx="5486400" cy="1005840"/>
+          </a:xfrm>
+          <a:prstGeom prst="rect">
+            <a:avLst/>
+          </a:prstGeom>
+          <a:noFill/>
+          <a:ln/>
+        </p:spPr>
+        <p:txBody>
+          <a:bodyPr wrap="square" lIns="0" tIns="0" rIns="0" bIns="0" rtlCol="0" anchor="ctr"/>
+          <a:lstStyle/>
+          <a:p>
+            <a:pPr indent="0" marL="0">
+              <a:lnSpc>
+                <a:spcPts val="2100"/>
+              </a:lnSpc>
+              <a:buNone/>
+            </a:pPr>
+            <a:r>
+              <a:rPr lang="en-US" sz="1400" dirty="0">
                 <a:solidFill>
                   <a:srgbClr val="9A93AD"/>
                 </a:solidFill>
@@ -2676,260 +2729,307 @@
                 <a:ea typeface="Calibri" pitchFamily="34" charset="-122"/>
                 <a:cs typeface="Calibri" pitchFamily="34" charset="-120"/>
               </a:rPr>
-              <a:t>CHAINS SUPPORTED</a:t>
-            </a:r>
-            <a:endParaRPr lang="en-US" sz="1000" dirty="0"/>
-          </a:p>
-        </p:txBody>
-      </p:sp>
-      <p:sp>
-        <p:nvSpPr>
-          <p:cNvPr id="6" name="Text 4"/>
-          <p:cNvSpPr txBox="1"/>
-          <p:nvPr/>
-        </p:nvSpPr>
-        <p:spPr>
-          <a:xfrm>
-            <a:off x="3520440" y="1709928"/>
-            <a:ext cx="2743200" cy="713232"/>
-          </a:xfrm>
-          <a:prstGeom prst="rect">
-            <a:avLst/>
-          </a:prstGeom>
-          <a:noFill/>
-          <a:ln/>
-        </p:spPr>
-        <p:txBody>
-          <a:bodyPr wrap="square" lIns="0" tIns="0" rIns="0" bIns="0" rtlCol="0" anchor="ctr"/>
-          <a:lstStyle/>
-          <a:p>
-            <a:pPr indent="0" marL="0">
-              <a:buNone/>
-            </a:pPr>
-            <a:r>
-              <a:rPr lang="en-US" sz="4000" b="1" dirty="0">
-                <a:solidFill>
-                  <a:srgbClr val="3D9A6D"/>
-                </a:solidFill>
-                <a:latin typeface="Cambria" pitchFamily="34" charset="0"/>
-                <a:ea typeface="Cambria" pitchFamily="34" charset="-122"/>
-                <a:cs typeface="Cambria" pitchFamily="34" charset="-120"/>
-              </a:rPr>
-              <a:t>0s</a:t>
-            </a:r>
-            <a:endParaRPr lang="en-US" sz="4000" dirty="0"/>
-          </a:p>
-        </p:txBody>
-      </p:sp>
-      <p:sp>
-        <p:nvSpPr>
-          <p:cNvPr id="7" name="Text 5"/>
-          <p:cNvSpPr txBox="1"/>
-          <p:nvPr/>
-        </p:nvSpPr>
-        <p:spPr>
-          <a:xfrm>
-            <a:off x="3520440" y="2404872"/>
-            <a:ext cx="2743200" cy="237744"/>
-          </a:xfrm>
-          <a:prstGeom prst="rect">
-            <a:avLst/>
-          </a:prstGeom>
-          <a:noFill/>
-          <a:ln/>
-        </p:spPr>
-        <p:txBody>
-          <a:bodyPr wrap="square" lIns="0" tIns="0" rIns="0" bIns="0" rtlCol="0" anchor="ctr"/>
-          <a:lstStyle/>
-          <a:p>
-            <a:pPr indent="0" marL="0">
-              <a:buNone/>
-            </a:pPr>
-            <a:r>
-              <a:rPr lang="en-US" sz="1000" b="1" spc="120" kern="0" dirty="0">
-                <a:solidFill>
-                  <a:srgbClr val="9A93AD"/>
-                </a:solidFill>
-                <a:latin typeface="Calibri" pitchFamily="34" charset="0"/>
-                <a:ea typeface="Calibri" pitchFamily="34" charset="-122"/>
-                <a:cs typeface="Calibri" pitchFamily="34" charset="-120"/>
-              </a:rPr>
-              <a:t>REPLAYED FROM CACHE</a:t>
-            </a:r>
-            <a:endParaRPr lang="en-US" sz="1000" dirty="0"/>
-          </a:p>
-        </p:txBody>
-      </p:sp>
-      <p:sp>
-        <p:nvSpPr>
-          <p:cNvPr id="8" name="Text 6"/>
-          <p:cNvSpPr txBox="1"/>
-          <p:nvPr/>
-        </p:nvSpPr>
-        <p:spPr>
-          <a:xfrm>
-            <a:off x="6473952" y="1709928"/>
-            <a:ext cx="2743200" cy="713232"/>
-          </a:xfrm>
-          <a:prstGeom prst="rect">
-            <a:avLst/>
-          </a:prstGeom>
-          <a:noFill/>
-          <a:ln/>
-        </p:spPr>
-        <p:txBody>
-          <a:bodyPr wrap="square" lIns="0" tIns="0" rIns="0" bIns="0" rtlCol="0" anchor="ctr"/>
-          <a:lstStyle/>
-          <a:p>
-            <a:pPr indent="0" marL="0">
-              <a:buNone/>
-            </a:pPr>
-            <a:r>
-              <a:rPr lang="en-US" sz="4000" b="1" dirty="0">
-                <a:solidFill>
-                  <a:srgbClr val="EDEAF3"/>
-                </a:solidFill>
-                <a:latin typeface="Cambria" pitchFamily="34" charset="0"/>
-                <a:ea typeface="Cambria" pitchFamily="34" charset="-122"/>
-                <a:cs typeface="Cambria" pitchFamily="34" charset="-120"/>
-              </a:rPr>
-              <a:t>auto</a:t>
-            </a:r>
-            <a:endParaRPr lang="en-US" sz="4000" dirty="0"/>
-          </a:p>
-        </p:txBody>
-      </p:sp>
-      <p:sp>
-        <p:nvSpPr>
-          <p:cNvPr id="9" name="Text 7"/>
-          <p:cNvSpPr txBox="1"/>
-          <p:nvPr/>
-        </p:nvSpPr>
-        <p:spPr>
-          <a:xfrm>
-            <a:off x="6473952" y="2404872"/>
-            <a:ext cx="2743200" cy="237744"/>
-          </a:xfrm>
-          <a:prstGeom prst="rect">
-            <a:avLst/>
-          </a:prstGeom>
-          <a:noFill/>
-          <a:ln/>
-        </p:spPr>
-        <p:txBody>
-          <a:bodyPr wrap="square" lIns="0" tIns="0" rIns="0" bIns="0" rtlCol="0" anchor="ctr"/>
-          <a:lstStyle/>
-          <a:p>
-            <a:pPr indent="0" marL="0">
-              <a:buNone/>
-            </a:pPr>
-            <a:r>
-              <a:rPr lang="en-US" sz="1000" b="1" spc="120" kern="0" dirty="0">
-                <a:solidFill>
-                  <a:srgbClr val="9A93AD"/>
-                </a:solidFill>
-                <a:latin typeface="Calibri" pitchFamily="34" charset="0"/>
-                <a:ea typeface="Calibri" pitchFamily="34" charset="-122"/>
-                <a:cs typeface="Calibri" pitchFamily="34" charset="-120"/>
-              </a:rPr>
-              <a:t>CHAIN DETECTION</a:t>
-            </a:r>
-            <a:endParaRPr lang="en-US" sz="1000" dirty="0"/>
-          </a:p>
-        </p:txBody>
-      </p:sp>
-      <p:sp>
-        <p:nvSpPr>
-          <p:cNvPr id="10" name="Text 8"/>
-          <p:cNvSpPr txBox="1"/>
-          <p:nvPr/>
-        </p:nvSpPr>
-        <p:spPr>
-          <a:xfrm>
-            <a:off x="9427464" y="1709928"/>
-            <a:ext cx="2194560" cy="713232"/>
-          </a:xfrm>
-          <a:prstGeom prst="rect">
-            <a:avLst/>
-          </a:prstGeom>
-          <a:noFill/>
-          <a:ln/>
-        </p:spPr>
-        <p:txBody>
-          <a:bodyPr wrap="square" lIns="0" tIns="0" rIns="0" bIns="0" rtlCol="0" anchor="ctr"/>
-          <a:lstStyle/>
-          <a:p>
-            <a:pPr indent="0" marL="0">
-              <a:buNone/>
-            </a:pPr>
-            <a:r>
-              <a:rPr lang="en-US" sz="4000" b="1" dirty="0">
-                <a:solidFill>
-                  <a:srgbClr val="EDEAF3"/>
-                </a:solidFill>
-                <a:latin typeface="Cambria" pitchFamily="34" charset="0"/>
-                <a:ea typeface="Cambria" pitchFamily="34" charset="-122"/>
-                <a:cs typeface="Cambria" pitchFamily="34" charset="-120"/>
-              </a:rPr>
-              <a:t>4</a:t>
-            </a:r>
-            <a:endParaRPr lang="en-US" sz="4000" dirty="0"/>
-          </a:p>
-        </p:txBody>
-      </p:sp>
-      <p:sp>
-        <p:nvSpPr>
-          <p:cNvPr id="11" name="Text 9"/>
-          <p:cNvSpPr txBox="1"/>
-          <p:nvPr/>
-        </p:nvSpPr>
-        <p:spPr>
-          <a:xfrm>
-            <a:off x="9427464" y="2404872"/>
-            <a:ext cx="2194560" cy="237744"/>
-          </a:xfrm>
-          <a:prstGeom prst="rect">
-            <a:avLst/>
-          </a:prstGeom>
-          <a:noFill/>
-          <a:ln/>
-        </p:spPr>
-        <p:txBody>
-          <a:bodyPr wrap="square" lIns="0" tIns="0" rIns="0" bIns="0" rtlCol="0" anchor="ctr"/>
-          <a:lstStyle/>
-          <a:p>
-            <a:pPr indent="0" marL="0">
-              <a:buNone/>
-            </a:pPr>
-            <a:r>
-              <a:rPr lang="en-US" sz="1000" b="1" spc="120" kern="0" dirty="0">
-                <a:solidFill>
-                  <a:srgbClr val="9A93AD"/>
-                </a:solidFill>
-                <a:latin typeface="Calibri" pitchFamily="34" charset="0"/>
-                <a:ea typeface="Calibri" pitchFamily="34" charset="-122"/>
-                <a:cs typeface="Calibri" pitchFamily="34" charset="-120"/>
-              </a:rPr>
-              <a:t>ENDPOINTS MERGED</a:t>
-            </a:r>
-            <a:endParaRPr lang="en-US" sz="1000" dirty="0"/>
-          </a:p>
-        </p:txBody>
-      </p:sp>
-      <p:sp>
-        <p:nvSpPr>
-          <p:cNvPr id="12" name="Shape 10"/>
+              <a:t>The SHA-256 of each ingested file is written to a public blockchain. That record sits outside this system — so if the machine is later compromised, rebuilt, or its database rewritten, the fact that the file existed in that exact form still stands.</a:t>
+            </a:r>
+            <a:endParaRPr lang="en-US" sz="1400" dirty="0"/>
+          </a:p>
+        </p:txBody>
+      </p:sp>
+      <p:sp>
+        <p:nvSpPr>
+          <p:cNvPr id="5" name="Shape 3"/>
           <p:cNvSpPr/>
           <p:nvPr/>
         </p:nvSpPr>
         <p:spPr>
           <a:xfrm>
-            <a:off x="566928" y="3172968"/>
-            <a:ext cx="5486400" cy="2103120"/>
+            <a:off x="566928" y="2761488"/>
+            <a:ext cx="1097280" cy="274320"/>
           </a:xfrm>
           <a:prstGeom prst="roundRect">
             <a:avLst>
-              <a:gd name="adj" fmla="val 1304"/>
+              <a:gd name="adj" fmla="val 16667"/>
+            </a:avLst>
+          </a:prstGeom>
+          <a:solidFill>
+            <a:srgbClr val="251F34"/>
+          </a:solidFill>
+          <a:ln w="12700">
+            <a:solidFill>
+              <a:srgbClr val="3D9A6D"/>
+            </a:solidFill>
+            <a:prstDash val="solid"/>
+          </a:ln>
+        </p:spPr>
+      </p:sp>
+      <p:sp>
+        <p:nvSpPr>
+          <p:cNvPr id="6" name="Text 4"/>
+          <p:cNvSpPr txBox="1"/>
+          <p:nvPr/>
+        </p:nvSpPr>
+        <p:spPr>
+          <a:xfrm>
+            <a:off x="566928" y="2761488"/>
+            <a:ext cx="1097280" cy="274320"/>
+          </a:xfrm>
+          <a:prstGeom prst="rect">
+            <a:avLst/>
+          </a:prstGeom>
+          <a:noFill/>
+          <a:ln/>
+        </p:spPr>
+        <p:txBody>
+          <a:bodyPr wrap="square" lIns="0" tIns="0" rIns="0" bIns="0" rtlCol="0" anchor="ctr"/>
+          <a:lstStyle/>
+          <a:p>
+            <a:pPr algn="ctr" indent="0" marL="0">
+              <a:buNone/>
+            </a:pPr>
+            <a:r>
+              <a:rPr lang="en-US" sz="1000" b="1" dirty="0">
+                <a:solidFill>
+                  <a:srgbClr val="3D9A6D"/>
+                </a:solidFill>
+                <a:latin typeface="Calibri" pitchFamily="34" charset="0"/>
+                <a:ea typeface="Calibri" pitchFamily="34" charset="-122"/>
+                <a:cs typeface="Calibri" pitchFamily="34" charset="-120"/>
+              </a:rPr>
+              <a:t>PROVES</a:t>
+            </a:r>
+            <a:endParaRPr lang="en-US" sz="1000" dirty="0"/>
+          </a:p>
+        </p:txBody>
+      </p:sp>
+      <p:sp>
+        <p:nvSpPr>
+          <p:cNvPr id="7" name="Text 5"/>
+          <p:cNvSpPr txBox="1"/>
+          <p:nvPr/>
+        </p:nvSpPr>
+        <p:spPr>
+          <a:xfrm>
+            <a:off x="566928" y="3145536"/>
+            <a:ext cx="5486400" cy="1097280"/>
+          </a:xfrm>
+          <a:prstGeom prst="rect">
+            <a:avLst/>
+          </a:prstGeom>
+          <a:noFill/>
+          <a:ln/>
+        </p:spPr>
+        <p:txBody>
+          <a:bodyPr wrap="square" lIns="0" tIns="0" rIns="0" bIns="0" rtlCol="0" anchor="ctr"/>
+          <a:lstStyle/>
+          <a:p>
+            <a:pPr marL="342900" indent="-342900">
+              <a:spcAft>
+                <a:spcPts val="600"/>
+              </a:spcAft>
+              <a:buSzPct val="100000"/>
+              <a:buChar char="•"/>
+            </a:pPr>
+            <a:r>
+              <a:rPr lang="en-US" sz="1300" dirty="0">
+                <a:solidFill>
+                  <a:srgbClr val="EDEAF3"/>
+                </a:solidFill>
+                <a:latin typeface="Calibri" pitchFamily="34" charset="0"/>
+                <a:ea typeface="Calibri" pitchFamily="34" charset="-122"/>
+                <a:cs typeface="Calibri" pitchFamily="34" charset="-120"/>
+              </a:rPr>
+              <a:t>the digest existed at or before that block</a:t>
+            </a:r>
+            <a:endParaRPr lang="en-US" sz="1300" dirty="0"/>
+          </a:p>
+          <a:p>
+            <a:pPr marL="342900" indent="-342900">
+              <a:spcAft>
+                <a:spcPts val="600"/>
+              </a:spcAft>
+              <a:buSzPct val="100000"/>
+              <a:buChar char="•"/>
+            </a:pPr>
+            <a:r>
+              <a:rPr lang="en-US" sz="1300" dirty="0">
+                <a:solidFill>
+                  <a:srgbClr val="EDEAF3"/>
+                </a:solidFill>
+                <a:latin typeface="Calibri" pitchFamily="34" charset="0"/>
+                <a:ea typeface="Calibri" pitchFamily="34" charset="-122"/>
+                <a:cs typeface="Calibri" pitchFamily="34" charset="-120"/>
+              </a:rPr>
+              <a:t>the record cannot afterwards be revised</a:t>
+            </a:r>
+            <a:endParaRPr lang="en-US" sz="1300" dirty="0"/>
+          </a:p>
+          <a:p>
+            <a:pPr marL="342900" indent="-342900">
+              <a:spcAft>
+                <a:spcPts val="600"/>
+              </a:spcAft>
+              <a:buSzPct val="100000"/>
+              <a:buChar char="•"/>
+            </a:pPr>
+            <a:r>
+              <a:rPr lang="en-US" sz="1300" dirty="0">
+                <a:solidFill>
+                  <a:srgbClr val="EDEAF3"/>
+                </a:solidFill>
+                <a:latin typeface="Calibri" pitchFamily="34" charset="0"/>
+                <a:ea typeface="Calibri" pitchFamily="34" charset="-122"/>
+                <a:cs typeface="Calibri" pitchFamily="34" charset="-120"/>
+              </a:rPr>
+              <a:t>a substituted document no longer matches</a:t>
+            </a:r>
+            <a:endParaRPr lang="en-US" sz="1300" dirty="0"/>
+          </a:p>
+        </p:txBody>
+      </p:sp>
+      <p:sp>
+        <p:nvSpPr>
+          <p:cNvPr id="8" name="Shape 6"/>
+          <p:cNvSpPr/>
+          <p:nvPr/>
+        </p:nvSpPr>
+        <p:spPr>
+          <a:xfrm>
+            <a:off x="566928" y="4315968"/>
+            <a:ext cx="1828800" cy="274320"/>
+          </a:xfrm>
+          <a:prstGeom prst="roundRect">
+            <a:avLst>
+              <a:gd name="adj" fmla="val 16667"/>
+            </a:avLst>
+          </a:prstGeom>
+          <a:solidFill>
+            <a:srgbClr val="251F34"/>
+          </a:solidFill>
+          <a:ln w="12700">
+            <a:solidFill>
+              <a:srgbClr val="E5484D"/>
+            </a:solidFill>
+            <a:prstDash val="solid"/>
+          </a:ln>
+        </p:spPr>
+      </p:sp>
+      <p:sp>
+        <p:nvSpPr>
+          <p:cNvPr id="9" name="Text 7"/>
+          <p:cNvSpPr txBox="1"/>
+          <p:nvPr/>
+        </p:nvSpPr>
+        <p:spPr>
+          <a:xfrm>
+            <a:off x="566928" y="4315968"/>
+            <a:ext cx="1828800" cy="274320"/>
+          </a:xfrm>
+          <a:prstGeom prst="rect">
+            <a:avLst/>
+          </a:prstGeom>
+          <a:noFill/>
+          <a:ln/>
+        </p:spPr>
+        <p:txBody>
+          <a:bodyPr wrap="square" lIns="0" tIns="0" rIns="0" bIns="0" rtlCol="0" anchor="ctr"/>
+          <a:lstStyle/>
+          <a:p>
+            <a:pPr algn="ctr" indent="0" marL="0">
+              <a:buNone/>
+            </a:pPr>
+            <a:r>
+              <a:rPr lang="en-US" sz="1000" b="1" dirty="0">
+                <a:solidFill>
+                  <a:srgbClr val="E5484D"/>
+                </a:solidFill>
+                <a:latin typeface="Calibri" pitchFamily="34" charset="0"/>
+                <a:ea typeface="Calibri" pitchFamily="34" charset="-122"/>
+                <a:cs typeface="Calibri" pitchFamily="34" charset="-120"/>
+              </a:rPr>
+              <a:t>DOES NOT PROVE</a:t>
+            </a:r>
+            <a:endParaRPr lang="en-US" sz="1000" dirty="0"/>
+          </a:p>
+        </p:txBody>
+      </p:sp>
+      <p:sp>
+        <p:nvSpPr>
+          <p:cNvPr id="10" name="Text 8"/>
+          <p:cNvSpPr txBox="1"/>
+          <p:nvPr/>
+        </p:nvSpPr>
+        <p:spPr>
+          <a:xfrm>
+            <a:off x="566928" y="4700016"/>
+            <a:ext cx="5486400" cy="822960"/>
+          </a:xfrm>
+          <a:prstGeom prst="rect">
+            <a:avLst/>
+          </a:prstGeom>
+          <a:noFill/>
+          <a:ln/>
+        </p:spPr>
+        <p:txBody>
+          <a:bodyPr wrap="square" lIns="0" tIns="0" rIns="0" bIns="0" rtlCol="0" anchor="ctr"/>
+          <a:lstStyle/>
+          <a:p>
+            <a:pPr marL="342900" indent="-342900">
+              <a:spcAft>
+                <a:spcPts val="600"/>
+              </a:spcAft>
+              <a:buSzPct val="100000"/>
+              <a:buChar char="•"/>
+            </a:pPr>
+            <a:r>
+              <a:rPr lang="en-US" sz="1300" dirty="0">
+                <a:solidFill>
+                  <a:srgbClr val="9A93AD"/>
+                </a:solidFill>
+                <a:latin typeface="Calibri" pitchFamily="34" charset="0"/>
+                <a:ea typeface="Calibri" pitchFamily="34" charset="-122"/>
+                <a:cs typeface="Calibri" pitchFamily="34" charset="-120"/>
+              </a:rPr>
+              <a:t>who created the document — anyone may anchor any digest</a:t>
+            </a:r>
+            <a:endParaRPr lang="en-US" sz="1300" dirty="0"/>
+          </a:p>
+          <a:p>
+            <a:pPr marL="342900" indent="-342900">
+              <a:spcAft>
+                <a:spcPts val="600"/>
+              </a:spcAft>
+              <a:buSzPct val="100000"/>
+              <a:buChar char="•"/>
+            </a:pPr>
+            <a:r>
+              <a:rPr lang="en-US" sz="1300" dirty="0">
+                <a:solidFill>
+                  <a:srgbClr val="9A93AD"/>
+                </a:solidFill>
+                <a:latin typeface="Calibri" pitchFamily="34" charset="0"/>
+                <a:ea typeface="Calibri" pitchFamily="34" charset="-122"/>
+                <a:cs typeface="Calibri" pitchFamily="34" charset="-120"/>
+              </a:rPr>
+              <a:t>that the document is tamper-PROOF — only tamper-EVIDENT</a:t>
+            </a:r>
+            <a:endParaRPr lang="en-US" sz="1300" dirty="0"/>
+          </a:p>
+        </p:txBody>
+      </p:sp>
+      <p:sp>
+        <p:nvSpPr>
+          <p:cNvPr id="11" name="Shape 9"/>
+          <p:cNvSpPr/>
+          <p:nvPr/>
+        </p:nvSpPr>
+        <p:spPr>
+          <a:xfrm>
+            <a:off x="6355080" y="1572768"/>
+            <a:ext cx="5276088" cy="3977640"/>
+          </a:xfrm>
+          <a:prstGeom prst="roundRect">
+            <a:avLst>
+              <a:gd name="adj" fmla="val 690"/>
             </a:avLst>
           </a:prstGeom>
           <a:solidFill>
@@ -2945,30 +3045,280 @@
       </p:sp>
       <p:sp>
         <p:nvSpPr>
+          <p:cNvPr id="12" name="Text 10"/>
+          <p:cNvSpPr txBox="1"/>
+          <p:nvPr/>
+        </p:nvSpPr>
+        <p:spPr>
+          <a:xfrm>
+            <a:off x="6656832" y="1828800"/>
+            <a:ext cx="4663440" cy="274320"/>
+          </a:xfrm>
+          <a:prstGeom prst="rect">
+            <a:avLst/>
+          </a:prstGeom>
+          <a:noFill/>
+          <a:ln/>
+        </p:spPr>
+        <p:txBody>
+          <a:bodyPr wrap="square" lIns="0" tIns="0" rIns="0" bIns="0" rtlCol="0" anchor="ctr"/>
+          <a:lstStyle/>
+          <a:p>
+            <a:pPr indent="0" marL="0">
+              <a:buNone/>
+            </a:pPr>
+            <a:r>
+              <a:rPr lang="en-US" sz="1200" dirty="0">
+                <a:solidFill>
+                  <a:srgbClr val="8B6FD4"/>
+                </a:solidFill>
+                <a:latin typeface="Courier New" pitchFamily="34" charset="0"/>
+                <a:ea typeface="Courier New" pitchFamily="34" charset="-122"/>
+                <a:cs typeface="Courier New" pitchFamily="34" charset="-120"/>
+              </a:rPr>
+              <a:t>EvidenceAnchor.sol</a:t>
+            </a:r>
+            <a:endParaRPr lang="en-US" sz="1200" dirty="0"/>
+          </a:p>
+        </p:txBody>
+      </p:sp>
+      <p:sp>
+        <p:nvSpPr>
           <p:cNvPr id="13" name="Text 11"/>
           <p:cNvSpPr txBox="1"/>
           <p:nvPr/>
         </p:nvSpPr>
         <p:spPr>
           <a:xfrm>
-            <a:off x="868680" y="3401568"/>
-            <a:ext cx="4937760" cy="329184"/>
-          </a:xfrm>
-          <a:prstGeom prst="rect">
-            <a:avLst/>
-          </a:prstGeom>
-          <a:noFill/>
-          <a:ln/>
-        </p:spPr>
-        <p:txBody>
-          <a:bodyPr wrap="square" lIns="0" tIns="0" rIns="0" bIns="0" rtlCol="0" anchor="ctr"/>
-          <a:lstStyle/>
-          <a:p>
-            <a:pPr indent="0" marL="0">
-              <a:buNone/>
-            </a:pPr>
-            <a:r>
-              <a:rPr lang="en-US" sz="1400" b="1" dirty="0">
+            <a:off x="6656832" y="2176272"/>
+            <a:ext cx="4663440" cy="1920240"/>
+          </a:xfrm>
+          <a:prstGeom prst="rect">
+            <a:avLst/>
+          </a:prstGeom>
+          <a:noFill/>
+          <a:ln/>
+        </p:spPr>
+        <p:txBody>
+          <a:bodyPr wrap="square" lIns="0" tIns="0" rIns="0" bIns="0" rtlCol="0" anchor="ctr"/>
+          <a:lstStyle/>
+          <a:p>
+            <a:pPr indent="0" marL="0">
+              <a:lnSpc>
+                <a:spcPts val="1300"/>
+              </a:lnSpc>
+              <a:buNone/>
+            </a:pPr>
+            <a:r>
+              <a:rPr lang="en-US" sz="950" dirty="0">
+                <a:solidFill>
+                  <a:srgbClr val="9A93AD"/>
+                </a:solidFill>
+                <a:latin typeface="Courier New" pitchFamily="34" charset="0"/>
+                <a:ea typeface="Courier New" pitchFamily="34" charset="-122"/>
+                <a:cs typeface="Courier New" pitchFamily="34" charset="-120"/>
+              </a:rPr>
+              <a:t>function anchor(bytes32 digest) external {</a:t>
+            </a:r>
+            <a:endParaRPr lang="en-US" sz="950" dirty="0"/>
+          </a:p>
+          <a:p>
+            <a:pPr indent="0" marL="0">
+              <a:lnSpc>
+                <a:spcPts val="1300"/>
+              </a:lnSpc>
+              <a:buNone/>
+            </a:pPr>
+            <a:r>
+              <a:rPr lang="en-US" sz="950" dirty="0">
+                <a:solidFill>
+                  <a:srgbClr val="9A93AD"/>
+                </a:solidFill>
+                <a:latin typeface="Courier New" pitchFamily="34" charset="0"/>
+                <a:ea typeface="Courier New" pitchFamily="34" charset="-122"/>
+                <a:cs typeface="Courier New" pitchFamily="34" charset="-120"/>
+              </a:rPr>
+              <a:t>    if (_anchors[digest].blockNumber != 0)</a:t>
+            </a:r>
+            <a:endParaRPr lang="en-US" sz="950" dirty="0"/>
+          </a:p>
+          <a:p>
+            <a:pPr indent="0" marL="0">
+              <a:lnSpc>
+                <a:spcPts val="1300"/>
+              </a:lnSpc>
+              <a:buNone/>
+            </a:pPr>
+            <a:r>
+              <a:rPr lang="en-US" sz="950" dirty="0">
+                <a:solidFill>
+                  <a:srgbClr val="9A93AD"/>
+                </a:solidFill>
+                <a:latin typeface="Courier New" pitchFamily="34" charset="0"/>
+                <a:ea typeface="Courier New" pitchFamily="34" charset="-122"/>
+                <a:cs typeface="Courier New" pitchFamily="34" charset="-120"/>
+              </a:rPr>
+              <a:t>        revert AlreadyAnchored(...);</a:t>
+            </a:r>
+            <a:endParaRPr lang="en-US" sz="950" dirty="0"/>
+          </a:p>
+          <a:p>
+            <a:pPr indent="0" marL="0">
+              <a:lnSpc>
+                <a:spcPts val="1300"/>
+              </a:lnSpc>
+              <a:buNone/>
+            </a:pPr>
+            <a:endParaRPr lang="en-US" sz="950" dirty="0"/>
+          </a:p>
+          <a:p>
+            <a:pPr indent="0" marL="0">
+              <a:lnSpc>
+                <a:spcPts val="1300"/>
+              </a:lnSpc>
+              <a:buNone/>
+            </a:pPr>
+            <a:r>
+              <a:rPr lang="en-US" sz="950" dirty="0">
+                <a:solidFill>
+                  <a:srgbClr val="9A93AD"/>
+                </a:solidFill>
+                <a:latin typeface="Courier New" pitchFamily="34" charset="0"/>
+                <a:ea typeface="Courier New" pitchFamily="34" charset="-122"/>
+                <a:cs typeface="Courier New" pitchFamily="34" charset="-120"/>
+              </a:rPr>
+              <a:t>    _anchors[digest] = Anchor({</a:t>
+            </a:r>
+            <a:endParaRPr lang="en-US" sz="950" dirty="0"/>
+          </a:p>
+          <a:p>
+            <a:pPr indent="0" marL="0">
+              <a:lnSpc>
+                <a:spcPts val="1300"/>
+              </a:lnSpc>
+              <a:buNone/>
+            </a:pPr>
+            <a:r>
+              <a:rPr lang="en-US" sz="950" dirty="0">
+                <a:solidFill>
+                  <a:srgbClr val="9A93AD"/>
+                </a:solidFill>
+                <a:latin typeface="Courier New" pitchFamily="34" charset="0"/>
+                <a:ea typeface="Courier New" pitchFamily="34" charset="-122"/>
+                <a:cs typeface="Courier New" pitchFamily="34" charset="-120"/>
+              </a:rPr>
+              <a:t>        blockTime:   uint64(block.timestamp),</a:t>
+            </a:r>
+            <a:endParaRPr lang="en-US" sz="950" dirty="0"/>
+          </a:p>
+          <a:p>
+            <a:pPr indent="0" marL="0">
+              <a:lnSpc>
+                <a:spcPts val="1300"/>
+              </a:lnSpc>
+              <a:buNone/>
+            </a:pPr>
+            <a:r>
+              <a:rPr lang="en-US" sz="950" dirty="0">
+                <a:solidFill>
+                  <a:srgbClr val="9A93AD"/>
+                </a:solidFill>
+                <a:latin typeface="Courier New" pitchFamily="34" charset="0"/>
+                <a:ea typeface="Courier New" pitchFamily="34" charset="-122"/>
+                <a:cs typeface="Courier New" pitchFamily="34" charset="-120"/>
+              </a:rPr>
+              <a:t>        blockNumber: uint64(block.number),</a:t>
+            </a:r>
+            <a:endParaRPr lang="en-US" sz="950" dirty="0"/>
+          </a:p>
+          <a:p>
+            <a:pPr indent="0" marL="0">
+              <a:lnSpc>
+                <a:spcPts val="1300"/>
+              </a:lnSpc>
+              <a:buNone/>
+            </a:pPr>
+            <a:r>
+              <a:rPr lang="en-US" sz="950" dirty="0">
+                <a:solidFill>
+                  <a:srgbClr val="9A93AD"/>
+                </a:solidFill>
+                <a:latin typeface="Courier New" pitchFamily="34" charset="0"/>
+                <a:ea typeface="Courier New" pitchFamily="34" charset="-122"/>
+                <a:cs typeface="Courier New" pitchFamily="34" charset="-120"/>
+              </a:rPr>
+              <a:t>        anchoredBy:  msg.sender</a:t>
+            </a:r>
+            <a:endParaRPr lang="en-US" sz="950" dirty="0"/>
+          </a:p>
+          <a:p>
+            <a:pPr indent="0" marL="0">
+              <a:lnSpc>
+                <a:spcPts val="1300"/>
+              </a:lnSpc>
+              <a:buNone/>
+            </a:pPr>
+            <a:r>
+              <a:rPr lang="en-US" sz="950" dirty="0">
+                <a:solidFill>
+                  <a:srgbClr val="9A93AD"/>
+                </a:solidFill>
+                <a:latin typeface="Courier New" pitchFamily="34" charset="0"/>
+                <a:ea typeface="Courier New" pitchFamily="34" charset="-122"/>
+                <a:cs typeface="Courier New" pitchFamily="34" charset="-120"/>
+              </a:rPr>
+              <a:t>    });</a:t>
+            </a:r>
+            <a:endParaRPr lang="en-US" sz="950" dirty="0"/>
+          </a:p>
+          <a:p>
+            <a:pPr indent="0" marL="0">
+              <a:lnSpc>
+                <a:spcPts val="1300"/>
+              </a:lnSpc>
+              <a:buNone/>
+            </a:pPr>
+            <a:r>
+              <a:rPr lang="en-US" sz="950" dirty="0">
+                <a:solidFill>
+                  <a:srgbClr val="9A93AD"/>
+                </a:solidFill>
+                <a:latin typeface="Courier New" pitchFamily="34" charset="0"/>
+                <a:ea typeface="Courier New" pitchFamily="34" charset="-122"/>
+                <a:cs typeface="Courier New" pitchFamily="34" charset="-120"/>
+              </a:rPr>
+              <a:t>}</a:t>
+            </a:r>
+            <a:endParaRPr lang="en-US" sz="950" dirty="0"/>
+          </a:p>
+        </p:txBody>
+      </p:sp>
+      <p:sp>
+        <p:nvSpPr>
+          <p:cNvPr id="14" name="Text 12"/>
+          <p:cNvSpPr txBox="1"/>
+          <p:nvPr/>
+        </p:nvSpPr>
+        <p:spPr>
+          <a:xfrm>
+            <a:off x="6656832" y="4178808"/>
+            <a:ext cx="4663440" cy="256032"/>
+          </a:xfrm>
+          <a:prstGeom prst="rect">
+            <a:avLst/>
+          </a:prstGeom>
+          <a:noFill/>
+          <a:ln/>
+        </p:spPr>
+        <p:txBody>
+          <a:bodyPr wrap="square" lIns="0" tIns="0" rIns="0" bIns="0" rtlCol="0" anchor="ctr"/>
+          <a:lstStyle/>
+          <a:p>
+            <a:pPr indent="0" marL="0">
+              <a:buNone/>
+            </a:pPr>
+            <a:r>
+              <a:rPr lang="en-US" sz="1200" b="1" dirty="0">
                 <a:solidFill>
                   <a:srgbClr val="EDEAF3"/>
                 </a:solidFill>
@@ -2976,22 +3326,22 @@
                 <a:ea typeface="Calibri" pitchFamily="34" charset="-122"/>
                 <a:cs typeface="Calibri" pitchFamily="34" charset="-120"/>
               </a:rPr>
-              <a:t>Ethereum is not where the money goes</a:t>
-            </a:r>
-            <a:endParaRPr lang="en-US" sz="1400" dirty="0"/>
-          </a:p>
-        </p:txBody>
-      </p:sp>
-      <p:sp>
-        <p:nvSpPr>
-          <p:cNvPr id="14" name="Text 12"/>
-          <p:cNvSpPr txBox="1"/>
-          <p:nvPr/>
-        </p:nvSpPr>
-        <p:spPr>
-          <a:xfrm>
-            <a:off x="868680" y="3785616"/>
-            <a:ext cx="4937760" cy="1280160"/>
+              <a:t>First write wins.</a:t>
+            </a:r>
+            <a:endParaRPr lang="en-US" sz="1200" dirty="0"/>
+          </a:p>
+        </p:txBody>
+      </p:sp>
+      <p:sp>
+        <p:nvSpPr>
+          <p:cNvPr id="15" name="Text 13"/>
+          <p:cNvSpPr txBox="1"/>
+          <p:nvPr/>
+        </p:nvSpPr>
+        <p:spPr>
+          <a:xfrm>
+            <a:off x="6656832" y="4462272"/>
+            <a:ext cx="4663440" cy="914400"/>
           </a:xfrm>
           <a:prstGeom prst="rect">
             <a:avLst/>
@@ -3005,136 +3355,28 @@
           <a:p>
             <a:pPr indent="0" marL="0">
               <a:lnSpc>
-                <a:spcPts val="1800"/>
+                <a:spcPts val="1600"/>
               </a:lnSpc>
               <a:buNone/>
             </a:pPr>
             <a:r>
-              <a:rPr lang="en-US" sz="1250" dirty="0">
-                <a:solidFill>
-                  <a:srgbClr val="9A93AD"/>
-                </a:solidFill>
-                <a:latin typeface="Calibri" pitchFamily="34" charset="0"/>
-                <a:ea typeface="Calibri" pitchFamily="34" charset="-122"/>
-                <a:cs typeface="Calibri" pitchFamily="34" charset="-120"/>
-              </a:rPr>
-              <a:t>Indian fraud proceeds move as USDT on TRON, where a transfer costs cents. Paste 0x… and we read Ethereum; paste T… and we read Tron. The investigator never declares a chain.</a:t>
-            </a:r>
-            <a:endParaRPr lang="en-US" sz="1250" dirty="0"/>
-          </a:p>
-        </p:txBody>
-      </p:sp>
-      <p:sp>
-        <p:nvSpPr>
-          <p:cNvPr id="15" name="Shape 13"/>
-          <p:cNvSpPr/>
-          <p:nvPr/>
-        </p:nvSpPr>
-        <p:spPr>
-          <a:xfrm>
-            <a:off x="6355080" y="3172968"/>
-            <a:ext cx="5276088" cy="2103120"/>
-          </a:xfrm>
-          <a:prstGeom prst="roundRect">
-            <a:avLst>
-              <a:gd name="adj" fmla="val 1304"/>
-            </a:avLst>
-          </a:prstGeom>
-          <a:solidFill>
-            <a:srgbClr val="1C1828"/>
-          </a:solidFill>
-          <a:ln w="12700">
-            <a:solidFill>
-              <a:srgbClr val="3A3350"/>
-            </a:solidFill>
-            <a:prstDash val="solid"/>
-          </a:ln>
-        </p:spPr>
+              <a:rPr lang="en-US" sz="1150" dirty="0">
+                <a:solidFill>
+                  <a:srgbClr val="5F5A70"/>
+                </a:solidFill>
+                <a:latin typeface="Calibri" pitchFamily="34" charset="0"/>
+                <a:ea typeface="Calibri" pitchFamily="34" charset="-122"/>
+                <a:cs typeface="Calibri" pitchFamily="34" charset="-120"/>
+              </a:rPr>
+              <a:t>Re-anchoring reverts rather than overwriting. The earliest record is the evidentially meaningful one, and silently replacing it would let a later party claim an earlier document’s timestamp.</a:t>
+            </a:r>
+            <a:endParaRPr lang="en-US" sz="1150" dirty="0"/>
+          </a:p>
+        </p:txBody>
       </p:sp>
       <p:sp>
         <p:nvSpPr>
           <p:cNvPr id="16" name="Text 14"/>
-          <p:cNvSpPr txBox="1"/>
-          <p:nvPr/>
-        </p:nvSpPr>
-        <p:spPr>
-          <a:xfrm>
-            <a:off x="6656832" y="3401568"/>
-            <a:ext cx="4663440" cy="329184"/>
-          </a:xfrm>
-          <a:prstGeom prst="rect">
-            <a:avLst/>
-          </a:prstGeom>
-          <a:noFill/>
-          <a:ln/>
-        </p:spPr>
-        <p:txBody>
-          <a:bodyPr wrap="square" lIns="0" tIns="0" rIns="0" bIns="0" rtlCol="0" anchor="ctr"/>
-          <a:lstStyle/>
-          <a:p>
-            <a:pPr indent="0" marL="0">
-              <a:buNone/>
-            </a:pPr>
-            <a:r>
-              <a:rPr lang="en-US" sz="1400" b="1" dirty="0">
-                <a:solidFill>
-                  <a:srgbClr val="E5484D"/>
-                </a:solidFill>
-                <a:latin typeface="Calibri" pitchFamily="34" charset="0"/>
-                <a:ea typeface="Calibri" pitchFamily="34" charset="-122"/>
-                <a:cs typeface="Calibri" pitchFamily="34" charset="-120"/>
-              </a:rPr>
-              <a:t>On Tron, “USDT” is not proof of USDT</a:t>
-            </a:r>
-            <a:endParaRPr lang="en-US" sz="1400" dirty="0"/>
-          </a:p>
-        </p:txBody>
-      </p:sp>
-      <p:sp>
-        <p:nvSpPr>
-          <p:cNvPr id="17" name="Text 15"/>
-          <p:cNvSpPr txBox="1"/>
-          <p:nvPr/>
-        </p:nvSpPr>
-        <p:spPr>
-          <a:xfrm>
-            <a:off x="6656832" y="3785616"/>
-            <a:ext cx="4663440" cy="1280160"/>
-          </a:xfrm>
-          <a:prstGeom prst="rect">
-            <a:avLst/>
-          </a:prstGeom>
-          <a:noFill/>
-          <a:ln/>
-        </p:spPr>
-        <p:txBody>
-          <a:bodyPr wrap="square" lIns="0" tIns="0" rIns="0" bIns="0" rtlCol="0" anchor="ctr"/>
-          <a:lstStyle/>
-          <a:p>
-            <a:pPr indent="0" marL="0">
-              <a:lnSpc>
-                <a:spcPts val="1800"/>
-              </a:lnSpc>
-              <a:buNone/>
-            </a:pPr>
-            <a:r>
-              <a:rPr lang="en-US" sz="1250" dirty="0">
-                <a:solidFill>
-                  <a:srgbClr val="9A93AD"/>
-                </a:solidFill>
-                <a:latin typeface="Calibri" pitchFamily="34" charset="0"/>
-                <a:ea typeface="Calibri" pitchFamily="34" charset="-122"/>
-                <a:cs typeface="Calibri" pitchFamily="34" charset="-120"/>
-              </a:rPr>
-              <a:t>Anyone can deploy a token whose ticker reads USDT, and scammers do — to poison analysis. We verify the CONTRACT, never the symbol. On our first live trace that caught a 7.5-trillion fake transfer.</a:t>
-            </a:r>
-            <a:endParaRPr lang="en-US" sz="1250" dirty="0"/>
-          </a:p>
-        </p:txBody>
-      </p:sp>
-      <p:sp>
-        <p:nvSpPr>
-          <p:cNvPr id="18" name="Text 16"/>
           <p:cNvSpPr txBox="1"/>
           <p:nvPr/>
         </p:nvSpPr>
@@ -3165,7 +3407,7 @@
                 <a:ea typeface="Calibri" pitchFamily="34" charset="-122"/>
                 <a:cs typeface="Calibri" pitchFamily="34" charset="-120"/>
               </a:rPr>
-              <a:t>Every response is cached, so a pre-tested address still traces with the network unplugged. Demo addresses are OFAC-designated contracts and publicly labelled exchange wallets — never a private individual's.</a:t>
+              <a:t>Verification is read-only and needs no credentials — anyone auditing the dossier can check the anchor without access to our systems.</a:t>
             </a:r>
             <a:endParaRPr lang="en-US" sz="1000" dirty="0"/>
           </a:p>
@@ -3182,6 +3424,683 @@
 <file path=ppt/slides/slide11.xml><?xml version="1.0" encoding="utf-8"?>
 <p:sld xmlns:a="http://schemas.openxmlformats.org/drawingml/2006/main" xmlns:r="http://schemas.openxmlformats.org/officeDocument/2006/relationships" xmlns:p="http://schemas.openxmlformats.org/presentationml/2006/main">
   <p:cSld name="Slide 11">
+    <p:bg>
+      <p:bgPr>
+        <a:solidFill>
+          <a:srgbClr val="12101A"/>
+        </a:solidFill>
+      </p:bgPr>
+    </p:bg>
+    <p:spTree>
+      <p:nvGrpSpPr>
+        <p:cNvPr id="1" name=""/>
+        <p:cNvGrpSpPr/>
+        <p:nvPr/>
+      </p:nvGrpSpPr>
+      <p:grpSpPr>
+        <a:xfrm>
+          <a:off x="0" y="0"/>
+          <a:ext cx="0" cy="0"/>
+          <a:chOff x="0" y="0"/>
+          <a:chExt cx="0" cy="0"/>
+        </a:xfrm>
+      </p:grpSpPr>
+      <p:sp>
+        <p:nvSpPr>
+          <p:cNvPr id="2" name="Text 0"/>
+          <p:cNvSpPr txBox="1"/>
+          <p:nvPr/>
+        </p:nvSpPr>
+        <p:spPr>
+          <a:xfrm>
+            <a:off x="566928" y="384048"/>
+            <a:ext cx="11064240" cy="237744"/>
+          </a:xfrm>
+          <a:prstGeom prst="rect">
+            <a:avLst/>
+          </a:prstGeom>
+          <a:noFill/>
+          <a:ln/>
+        </p:spPr>
+        <p:txBody>
+          <a:bodyPr wrap="square" lIns="0" tIns="0" rIns="0" bIns="0" rtlCol="0" anchor="ctr"/>
+          <a:lstStyle/>
+          <a:p>
+            <a:pPr indent="0" marL="0">
+              <a:buNone/>
+            </a:pPr>
+            <a:r>
+              <a:rPr lang="en-US" sz="1100" b="1" spc="240" kern="0" dirty="0">
+                <a:solidFill>
+                  <a:srgbClr val="8B6FD4"/>
+                </a:solidFill>
+                <a:latin typeface="Calibri" pitchFamily="34" charset="0"/>
+                <a:ea typeface="Calibri" pitchFamily="34" charset="-122"/>
+                <a:cs typeface="Calibri" pitchFamily="34" charset="-120"/>
+              </a:rPr>
+              <a:t>NOT JUST OUR DATA</a:t>
+            </a:r>
+            <a:endParaRPr lang="en-US" sz="1100" dirty="0"/>
+          </a:p>
+        </p:txBody>
+      </p:sp>
+      <p:sp>
+        <p:nvSpPr>
+          <p:cNvPr id="3" name="Text 1"/>
+          <p:cNvSpPr txBox="1"/>
+          <p:nvPr/>
+        </p:nvSpPr>
+        <p:spPr>
+          <a:xfrm>
+            <a:off x="566928" y="658368"/>
+            <a:ext cx="11064240" cy="749808"/>
+          </a:xfrm>
+          <a:prstGeom prst="rect">
+            <a:avLst/>
+          </a:prstGeom>
+          <a:noFill/>
+          <a:ln/>
+        </p:spPr>
+        <p:txBody>
+          <a:bodyPr wrap="square" lIns="0" tIns="0" rIns="0" bIns="0" rtlCol="0" anchor="ctr"/>
+          <a:lstStyle/>
+          <a:p>
+            <a:pPr indent="0" marL="0">
+              <a:buNone/>
+            </a:pPr>
+            <a:r>
+              <a:rPr lang="en-US" sz="3400" b="1" dirty="0">
+                <a:solidFill>
+                  <a:srgbClr val="EDEAF3"/>
+                </a:solidFill>
+                <a:latin typeface="Cambria" pitchFamily="34" charset="0"/>
+                <a:ea typeface="Cambria" pitchFamily="34" charset="-122"/>
+                <a:cs typeface="Cambria" pitchFamily="34" charset="-120"/>
+              </a:rPr>
+              <a:t>Hand us a real address. It picks the chain itself.</a:t>
+            </a:r>
+            <a:endParaRPr lang="en-US" sz="3400" dirty="0"/>
+          </a:p>
+        </p:txBody>
+      </p:sp>
+      <p:sp>
+        <p:nvSpPr>
+          <p:cNvPr id="4" name="Text 2"/>
+          <p:cNvSpPr txBox="1"/>
+          <p:nvPr/>
+        </p:nvSpPr>
+        <p:spPr>
+          <a:xfrm>
+            <a:off x="566928" y="1709928"/>
+            <a:ext cx="2743200" cy="713232"/>
+          </a:xfrm>
+          <a:prstGeom prst="rect">
+            <a:avLst/>
+          </a:prstGeom>
+          <a:noFill/>
+          <a:ln/>
+        </p:spPr>
+        <p:txBody>
+          <a:bodyPr wrap="square" lIns="0" tIns="0" rIns="0" bIns="0" rtlCol="0" anchor="ctr"/>
+          <a:lstStyle/>
+          <a:p>
+            <a:pPr indent="0" marL="0">
+              <a:buNone/>
+            </a:pPr>
+            <a:r>
+              <a:rPr lang="en-US" sz="4000" b="1" dirty="0">
+                <a:solidFill>
+                  <a:srgbClr val="8B6FD4"/>
+                </a:solidFill>
+                <a:latin typeface="Cambria" pitchFamily="34" charset="0"/>
+                <a:ea typeface="Cambria" pitchFamily="34" charset="-122"/>
+                <a:cs typeface="Cambria" pitchFamily="34" charset="-120"/>
+              </a:rPr>
+              <a:t>2</a:t>
+            </a:r>
+            <a:endParaRPr lang="en-US" sz="4000" dirty="0"/>
+          </a:p>
+        </p:txBody>
+      </p:sp>
+      <p:sp>
+        <p:nvSpPr>
+          <p:cNvPr id="5" name="Text 3"/>
+          <p:cNvSpPr txBox="1"/>
+          <p:nvPr/>
+        </p:nvSpPr>
+        <p:spPr>
+          <a:xfrm>
+            <a:off x="566928" y="2404872"/>
+            <a:ext cx="2743200" cy="237744"/>
+          </a:xfrm>
+          <a:prstGeom prst="rect">
+            <a:avLst/>
+          </a:prstGeom>
+          <a:noFill/>
+          <a:ln/>
+        </p:spPr>
+        <p:txBody>
+          <a:bodyPr wrap="square" lIns="0" tIns="0" rIns="0" bIns="0" rtlCol="0" anchor="ctr"/>
+          <a:lstStyle/>
+          <a:p>
+            <a:pPr indent="0" marL="0">
+              <a:buNone/>
+            </a:pPr>
+            <a:r>
+              <a:rPr lang="en-US" sz="1000" b="1" spc="120" kern="0" dirty="0">
+                <a:solidFill>
+                  <a:srgbClr val="9A93AD"/>
+                </a:solidFill>
+                <a:latin typeface="Calibri" pitchFamily="34" charset="0"/>
+                <a:ea typeface="Calibri" pitchFamily="34" charset="-122"/>
+                <a:cs typeface="Calibri" pitchFamily="34" charset="-120"/>
+              </a:rPr>
+              <a:t>CHAINS SUPPORTED</a:t>
+            </a:r>
+            <a:endParaRPr lang="en-US" sz="1000" dirty="0"/>
+          </a:p>
+        </p:txBody>
+      </p:sp>
+      <p:sp>
+        <p:nvSpPr>
+          <p:cNvPr id="6" name="Text 4"/>
+          <p:cNvSpPr txBox="1"/>
+          <p:nvPr/>
+        </p:nvSpPr>
+        <p:spPr>
+          <a:xfrm>
+            <a:off x="3520440" y="1709928"/>
+            <a:ext cx="2743200" cy="713232"/>
+          </a:xfrm>
+          <a:prstGeom prst="rect">
+            <a:avLst/>
+          </a:prstGeom>
+          <a:noFill/>
+          <a:ln/>
+        </p:spPr>
+        <p:txBody>
+          <a:bodyPr wrap="square" lIns="0" tIns="0" rIns="0" bIns="0" rtlCol="0" anchor="ctr"/>
+          <a:lstStyle/>
+          <a:p>
+            <a:pPr indent="0" marL="0">
+              <a:buNone/>
+            </a:pPr>
+            <a:r>
+              <a:rPr lang="en-US" sz="4000" b="1" dirty="0">
+                <a:solidFill>
+                  <a:srgbClr val="3D9A6D"/>
+                </a:solidFill>
+                <a:latin typeface="Cambria" pitchFamily="34" charset="0"/>
+                <a:ea typeface="Cambria" pitchFamily="34" charset="-122"/>
+                <a:cs typeface="Cambria" pitchFamily="34" charset="-120"/>
+              </a:rPr>
+              <a:t>0s</a:t>
+            </a:r>
+            <a:endParaRPr lang="en-US" sz="4000" dirty="0"/>
+          </a:p>
+        </p:txBody>
+      </p:sp>
+      <p:sp>
+        <p:nvSpPr>
+          <p:cNvPr id="7" name="Text 5"/>
+          <p:cNvSpPr txBox="1"/>
+          <p:nvPr/>
+        </p:nvSpPr>
+        <p:spPr>
+          <a:xfrm>
+            <a:off x="3520440" y="2404872"/>
+            <a:ext cx="2743200" cy="237744"/>
+          </a:xfrm>
+          <a:prstGeom prst="rect">
+            <a:avLst/>
+          </a:prstGeom>
+          <a:noFill/>
+          <a:ln/>
+        </p:spPr>
+        <p:txBody>
+          <a:bodyPr wrap="square" lIns="0" tIns="0" rIns="0" bIns="0" rtlCol="0" anchor="ctr"/>
+          <a:lstStyle/>
+          <a:p>
+            <a:pPr indent="0" marL="0">
+              <a:buNone/>
+            </a:pPr>
+            <a:r>
+              <a:rPr lang="en-US" sz="1000" b="1" spc="120" kern="0" dirty="0">
+                <a:solidFill>
+                  <a:srgbClr val="9A93AD"/>
+                </a:solidFill>
+                <a:latin typeface="Calibri" pitchFamily="34" charset="0"/>
+                <a:ea typeface="Calibri" pitchFamily="34" charset="-122"/>
+                <a:cs typeface="Calibri" pitchFamily="34" charset="-120"/>
+              </a:rPr>
+              <a:t>REPLAYED FROM CACHE</a:t>
+            </a:r>
+            <a:endParaRPr lang="en-US" sz="1000" dirty="0"/>
+          </a:p>
+        </p:txBody>
+      </p:sp>
+      <p:sp>
+        <p:nvSpPr>
+          <p:cNvPr id="8" name="Text 6"/>
+          <p:cNvSpPr txBox="1"/>
+          <p:nvPr/>
+        </p:nvSpPr>
+        <p:spPr>
+          <a:xfrm>
+            <a:off x="6473952" y="1709928"/>
+            <a:ext cx="2743200" cy="713232"/>
+          </a:xfrm>
+          <a:prstGeom prst="rect">
+            <a:avLst/>
+          </a:prstGeom>
+          <a:noFill/>
+          <a:ln/>
+        </p:spPr>
+        <p:txBody>
+          <a:bodyPr wrap="square" lIns="0" tIns="0" rIns="0" bIns="0" rtlCol="0" anchor="ctr"/>
+          <a:lstStyle/>
+          <a:p>
+            <a:pPr indent="0" marL="0">
+              <a:buNone/>
+            </a:pPr>
+            <a:r>
+              <a:rPr lang="en-US" sz="4000" b="1" dirty="0">
+                <a:solidFill>
+                  <a:srgbClr val="EDEAF3"/>
+                </a:solidFill>
+                <a:latin typeface="Cambria" pitchFamily="34" charset="0"/>
+                <a:ea typeface="Cambria" pitchFamily="34" charset="-122"/>
+                <a:cs typeface="Cambria" pitchFamily="34" charset="-120"/>
+              </a:rPr>
+              <a:t>auto</a:t>
+            </a:r>
+            <a:endParaRPr lang="en-US" sz="4000" dirty="0"/>
+          </a:p>
+        </p:txBody>
+      </p:sp>
+      <p:sp>
+        <p:nvSpPr>
+          <p:cNvPr id="9" name="Text 7"/>
+          <p:cNvSpPr txBox="1"/>
+          <p:nvPr/>
+        </p:nvSpPr>
+        <p:spPr>
+          <a:xfrm>
+            <a:off x="6473952" y="2404872"/>
+            <a:ext cx="2743200" cy="237744"/>
+          </a:xfrm>
+          <a:prstGeom prst="rect">
+            <a:avLst/>
+          </a:prstGeom>
+          <a:noFill/>
+          <a:ln/>
+        </p:spPr>
+        <p:txBody>
+          <a:bodyPr wrap="square" lIns="0" tIns="0" rIns="0" bIns="0" rtlCol="0" anchor="ctr"/>
+          <a:lstStyle/>
+          <a:p>
+            <a:pPr indent="0" marL="0">
+              <a:buNone/>
+            </a:pPr>
+            <a:r>
+              <a:rPr lang="en-US" sz="1000" b="1" spc="120" kern="0" dirty="0">
+                <a:solidFill>
+                  <a:srgbClr val="9A93AD"/>
+                </a:solidFill>
+                <a:latin typeface="Calibri" pitchFamily="34" charset="0"/>
+                <a:ea typeface="Calibri" pitchFamily="34" charset="-122"/>
+                <a:cs typeface="Calibri" pitchFamily="34" charset="-120"/>
+              </a:rPr>
+              <a:t>CHAIN DETECTION</a:t>
+            </a:r>
+            <a:endParaRPr lang="en-US" sz="1000" dirty="0"/>
+          </a:p>
+        </p:txBody>
+      </p:sp>
+      <p:sp>
+        <p:nvSpPr>
+          <p:cNvPr id="10" name="Text 8"/>
+          <p:cNvSpPr txBox="1"/>
+          <p:nvPr/>
+        </p:nvSpPr>
+        <p:spPr>
+          <a:xfrm>
+            <a:off x="9427464" y="1709928"/>
+            <a:ext cx="2194560" cy="713232"/>
+          </a:xfrm>
+          <a:prstGeom prst="rect">
+            <a:avLst/>
+          </a:prstGeom>
+          <a:noFill/>
+          <a:ln/>
+        </p:spPr>
+        <p:txBody>
+          <a:bodyPr wrap="square" lIns="0" tIns="0" rIns="0" bIns="0" rtlCol="0" anchor="ctr"/>
+          <a:lstStyle/>
+          <a:p>
+            <a:pPr indent="0" marL="0">
+              <a:buNone/>
+            </a:pPr>
+            <a:r>
+              <a:rPr lang="en-US" sz="4000" b="1" dirty="0">
+                <a:solidFill>
+                  <a:srgbClr val="EDEAF3"/>
+                </a:solidFill>
+                <a:latin typeface="Cambria" pitchFamily="34" charset="0"/>
+                <a:ea typeface="Cambria" pitchFamily="34" charset="-122"/>
+                <a:cs typeface="Cambria" pitchFamily="34" charset="-120"/>
+              </a:rPr>
+              <a:t>4</a:t>
+            </a:r>
+            <a:endParaRPr lang="en-US" sz="4000" dirty="0"/>
+          </a:p>
+        </p:txBody>
+      </p:sp>
+      <p:sp>
+        <p:nvSpPr>
+          <p:cNvPr id="11" name="Text 9"/>
+          <p:cNvSpPr txBox="1"/>
+          <p:nvPr/>
+        </p:nvSpPr>
+        <p:spPr>
+          <a:xfrm>
+            <a:off x="9427464" y="2404872"/>
+            <a:ext cx="2194560" cy="237744"/>
+          </a:xfrm>
+          <a:prstGeom prst="rect">
+            <a:avLst/>
+          </a:prstGeom>
+          <a:noFill/>
+          <a:ln/>
+        </p:spPr>
+        <p:txBody>
+          <a:bodyPr wrap="square" lIns="0" tIns="0" rIns="0" bIns="0" rtlCol="0" anchor="ctr"/>
+          <a:lstStyle/>
+          <a:p>
+            <a:pPr indent="0" marL="0">
+              <a:buNone/>
+            </a:pPr>
+            <a:r>
+              <a:rPr lang="en-US" sz="1000" b="1" spc="120" kern="0" dirty="0">
+                <a:solidFill>
+                  <a:srgbClr val="9A93AD"/>
+                </a:solidFill>
+                <a:latin typeface="Calibri" pitchFamily="34" charset="0"/>
+                <a:ea typeface="Calibri" pitchFamily="34" charset="-122"/>
+                <a:cs typeface="Calibri" pitchFamily="34" charset="-120"/>
+              </a:rPr>
+              <a:t>ENDPOINTS MERGED</a:t>
+            </a:r>
+            <a:endParaRPr lang="en-US" sz="1000" dirty="0"/>
+          </a:p>
+        </p:txBody>
+      </p:sp>
+      <p:sp>
+        <p:nvSpPr>
+          <p:cNvPr id="12" name="Shape 10"/>
+          <p:cNvSpPr/>
+          <p:nvPr/>
+        </p:nvSpPr>
+        <p:spPr>
+          <a:xfrm>
+            <a:off x="566928" y="3172968"/>
+            <a:ext cx="5486400" cy="2103120"/>
+          </a:xfrm>
+          <a:prstGeom prst="roundRect">
+            <a:avLst>
+              <a:gd name="adj" fmla="val 1304"/>
+            </a:avLst>
+          </a:prstGeom>
+          <a:solidFill>
+            <a:srgbClr val="1C1828"/>
+          </a:solidFill>
+          <a:ln w="12700">
+            <a:solidFill>
+              <a:srgbClr val="3A3350"/>
+            </a:solidFill>
+            <a:prstDash val="solid"/>
+          </a:ln>
+        </p:spPr>
+      </p:sp>
+      <p:sp>
+        <p:nvSpPr>
+          <p:cNvPr id="13" name="Text 11"/>
+          <p:cNvSpPr txBox="1"/>
+          <p:nvPr/>
+        </p:nvSpPr>
+        <p:spPr>
+          <a:xfrm>
+            <a:off x="868680" y="3401568"/>
+            <a:ext cx="4937760" cy="329184"/>
+          </a:xfrm>
+          <a:prstGeom prst="rect">
+            <a:avLst/>
+          </a:prstGeom>
+          <a:noFill/>
+          <a:ln/>
+        </p:spPr>
+        <p:txBody>
+          <a:bodyPr wrap="square" lIns="0" tIns="0" rIns="0" bIns="0" rtlCol="0" anchor="ctr"/>
+          <a:lstStyle/>
+          <a:p>
+            <a:pPr indent="0" marL="0">
+              <a:buNone/>
+            </a:pPr>
+            <a:r>
+              <a:rPr lang="en-US" sz="1400" b="1" dirty="0">
+                <a:solidFill>
+                  <a:srgbClr val="EDEAF3"/>
+                </a:solidFill>
+                <a:latin typeface="Calibri" pitchFamily="34" charset="0"/>
+                <a:ea typeface="Calibri" pitchFamily="34" charset="-122"/>
+                <a:cs typeface="Calibri" pitchFamily="34" charset="-120"/>
+              </a:rPr>
+              <a:t>Ethereum is not where the money goes</a:t>
+            </a:r>
+            <a:endParaRPr lang="en-US" sz="1400" dirty="0"/>
+          </a:p>
+        </p:txBody>
+      </p:sp>
+      <p:sp>
+        <p:nvSpPr>
+          <p:cNvPr id="14" name="Text 12"/>
+          <p:cNvSpPr txBox="1"/>
+          <p:nvPr/>
+        </p:nvSpPr>
+        <p:spPr>
+          <a:xfrm>
+            <a:off x="868680" y="3785616"/>
+            <a:ext cx="4937760" cy="1280160"/>
+          </a:xfrm>
+          <a:prstGeom prst="rect">
+            <a:avLst/>
+          </a:prstGeom>
+          <a:noFill/>
+          <a:ln/>
+        </p:spPr>
+        <p:txBody>
+          <a:bodyPr wrap="square" lIns="0" tIns="0" rIns="0" bIns="0" rtlCol="0" anchor="ctr"/>
+          <a:lstStyle/>
+          <a:p>
+            <a:pPr indent="0" marL="0">
+              <a:lnSpc>
+                <a:spcPts val="1800"/>
+              </a:lnSpc>
+              <a:buNone/>
+            </a:pPr>
+            <a:r>
+              <a:rPr lang="en-US" sz="1250" dirty="0">
+                <a:solidFill>
+                  <a:srgbClr val="9A93AD"/>
+                </a:solidFill>
+                <a:latin typeface="Calibri" pitchFamily="34" charset="0"/>
+                <a:ea typeface="Calibri" pitchFamily="34" charset="-122"/>
+                <a:cs typeface="Calibri" pitchFamily="34" charset="-120"/>
+              </a:rPr>
+              <a:t>Indian fraud proceeds move as USDT on TRON, where a transfer costs cents. Paste 0x… and we read Ethereum; paste T… and we read Tron. The investigator never declares a chain.</a:t>
+            </a:r>
+            <a:endParaRPr lang="en-US" sz="1250" dirty="0"/>
+          </a:p>
+        </p:txBody>
+      </p:sp>
+      <p:sp>
+        <p:nvSpPr>
+          <p:cNvPr id="15" name="Shape 13"/>
+          <p:cNvSpPr/>
+          <p:nvPr/>
+        </p:nvSpPr>
+        <p:spPr>
+          <a:xfrm>
+            <a:off x="6355080" y="3172968"/>
+            <a:ext cx="5276088" cy="2103120"/>
+          </a:xfrm>
+          <a:prstGeom prst="roundRect">
+            <a:avLst>
+              <a:gd name="adj" fmla="val 1304"/>
+            </a:avLst>
+          </a:prstGeom>
+          <a:solidFill>
+            <a:srgbClr val="1C1828"/>
+          </a:solidFill>
+          <a:ln w="12700">
+            <a:solidFill>
+              <a:srgbClr val="3A3350"/>
+            </a:solidFill>
+            <a:prstDash val="solid"/>
+          </a:ln>
+        </p:spPr>
+      </p:sp>
+      <p:sp>
+        <p:nvSpPr>
+          <p:cNvPr id="16" name="Text 14"/>
+          <p:cNvSpPr txBox="1"/>
+          <p:nvPr/>
+        </p:nvSpPr>
+        <p:spPr>
+          <a:xfrm>
+            <a:off x="6656832" y="3401568"/>
+            <a:ext cx="4663440" cy="329184"/>
+          </a:xfrm>
+          <a:prstGeom prst="rect">
+            <a:avLst/>
+          </a:prstGeom>
+          <a:noFill/>
+          <a:ln/>
+        </p:spPr>
+        <p:txBody>
+          <a:bodyPr wrap="square" lIns="0" tIns="0" rIns="0" bIns="0" rtlCol="0" anchor="ctr"/>
+          <a:lstStyle/>
+          <a:p>
+            <a:pPr indent="0" marL="0">
+              <a:buNone/>
+            </a:pPr>
+            <a:r>
+              <a:rPr lang="en-US" sz="1400" b="1" dirty="0">
+                <a:solidFill>
+                  <a:srgbClr val="E5484D"/>
+                </a:solidFill>
+                <a:latin typeface="Calibri" pitchFamily="34" charset="0"/>
+                <a:ea typeface="Calibri" pitchFamily="34" charset="-122"/>
+                <a:cs typeface="Calibri" pitchFamily="34" charset="-120"/>
+              </a:rPr>
+              <a:t>On Tron, “USDT” is not proof of USDT</a:t>
+            </a:r>
+            <a:endParaRPr lang="en-US" sz="1400" dirty="0"/>
+          </a:p>
+        </p:txBody>
+      </p:sp>
+      <p:sp>
+        <p:nvSpPr>
+          <p:cNvPr id="17" name="Text 15"/>
+          <p:cNvSpPr txBox="1"/>
+          <p:nvPr/>
+        </p:nvSpPr>
+        <p:spPr>
+          <a:xfrm>
+            <a:off x="6656832" y="3785616"/>
+            <a:ext cx="4663440" cy="1280160"/>
+          </a:xfrm>
+          <a:prstGeom prst="rect">
+            <a:avLst/>
+          </a:prstGeom>
+          <a:noFill/>
+          <a:ln/>
+        </p:spPr>
+        <p:txBody>
+          <a:bodyPr wrap="square" lIns="0" tIns="0" rIns="0" bIns="0" rtlCol="0" anchor="ctr"/>
+          <a:lstStyle/>
+          <a:p>
+            <a:pPr indent="0" marL="0">
+              <a:lnSpc>
+                <a:spcPts val="1800"/>
+              </a:lnSpc>
+              <a:buNone/>
+            </a:pPr>
+            <a:r>
+              <a:rPr lang="en-US" sz="1250" dirty="0">
+                <a:solidFill>
+                  <a:srgbClr val="9A93AD"/>
+                </a:solidFill>
+                <a:latin typeface="Calibri" pitchFamily="34" charset="0"/>
+                <a:ea typeface="Calibri" pitchFamily="34" charset="-122"/>
+                <a:cs typeface="Calibri" pitchFamily="34" charset="-120"/>
+              </a:rPr>
+              <a:t>Anyone can deploy a token whose ticker reads USDT, and scammers do — to poison analysis. We verify the CONTRACT, never the symbol. On our first live trace that caught a 7.5-trillion fake transfer.</a:t>
+            </a:r>
+            <a:endParaRPr lang="en-US" sz="1250" dirty="0"/>
+          </a:p>
+        </p:txBody>
+      </p:sp>
+      <p:sp>
+        <p:nvSpPr>
+          <p:cNvPr id="18" name="Text 16"/>
+          <p:cNvSpPr txBox="1"/>
+          <p:nvPr/>
+        </p:nvSpPr>
+        <p:spPr>
+          <a:xfrm>
+            <a:off x="566928" y="6236208"/>
+            <a:ext cx="11064240" cy="365760"/>
+          </a:xfrm>
+          <a:prstGeom prst="rect">
+            <a:avLst/>
+          </a:prstGeom>
+          <a:noFill/>
+          <a:ln/>
+        </p:spPr>
+        <p:txBody>
+          <a:bodyPr wrap="square" lIns="0" tIns="0" rIns="0" bIns="0" rtlCol="0" anchor="ctr"/>
+          <a:lstStyle/>
+          <a:p>
+            <a:pPr indent="0" marL="0">
+              <a:buNone/>
+            </a:pPr>
+            <a:r>
+              <a:rPr lang="en-US" sz="1000" i="1" dirty="0">
+                <a:solidFill>
+                  <a:srgbClr val="5F5A70"/>
+                </a:solidFill>
+                <a:latin typeface="Calibri" pitchFamily="34" charset="0"/>
+                <a:ea typeface="Calibri" pitchFamily="34" charset="-122"/>
+                <a:cs typeface="Calibri" pitchFamily="34" charset="-120"/>
+              </a:rPr>
+              <a:t>Every response is cached, so a pre-tested address still traces with the network unplugged. Demo addresses are OFAC-designated contracts and publicly labelled exchange wallets — never a private individual's.</a:t>
+            </a:r>
+            <a:endParaRPr lang="en-US" sz="1000" dirty="0"/>
+          </a:p>
+        </p:txBody>
+      </p:sp>
+    </p:spTree>
+  </p:cSld>
+  <p:clrMapOvr>
+    <a:masterClrMapping/>
+  </p:clrMapOvr>
+</p:sld>
+</file>
+
+<file path=ppt/slides/slide12.xml><?xml version="1.0" encoding="utf-8"?>
+<p:sld xmlns:a="http://schemas.openxmlformats.org/drawingml/2006/main" xmlns:r="http://schemas.openxmlformats.org/officeDocument/2006/relationships" xmlns:p="http://schemas.openxmlformats.org/presentationml/2006/main">
+  <p:cSld name="Slide 12">
     <p:bg>
       <p:bgPr>
         <a:solidFill>
@@ -4552,9 +5471,9 @@
 </p:sld>
 </file>
 
-<file path=ppt/slides/slide12.xml><?xml version="1.0" encoding="utf-8"?>
+<file path=ppt/slides/slide13.xml><?xml version="1.0" encoding="utf-8"?>
 <p:sld xmlns:a="http://schemas.openxmlformats.org/drawingml/2006/main" xmlns:r="http://schemas.openxmlformats.org/officeDocument/2006/relationships" xmlns:p="http://schemas.openxmlformats.org/presentationml/2006/main">
-  <p:cSld name="Slide 12">
+  <p:cSld name="Slide 13">
     <p:bg>
       <p:bgPr>
         <a:solidFill>
@@ -4819,7 +5738,7 @@
                 <a:ea typeface="Calibri" pitchFamily="34" charset="-122"/>
                 <a:cs typeface="Calibri" pitchFamily="34" charset="-120"/>
               </a:rPr>
-              <a:t>14 entities, 17 transfers</a:t>
+              <a:t>2 chains</a:t>
             </a:r>
             <a:endParaRPr lang="en-US" sz="1300" dirty="0"/>
           </a:p>
@@ -4858,7 +5777,7 @@
                 <a:ea typeface="Calibri" pitchFamily="34" charset="-122"/>
                 <a:cs typeface="Calibri" pitchFamily="34" charset="-120"/>
               </a:rPr>
-              <a:t>reference case</a:t>
+              <a:t>Ethereum and Tron, auto-detected</a:t>
             </a:r>
             <a:endParaRPr lang="en-US" sz="1100" dirty="0"/>
           </a:p>
@@ -4897,7 +5816,7 @@
                 <a:ea typeface="Calibri" pitchFamily="34" charset="-122"/>
                 <a:cs typeface="Calibri" pitchFamily="34" charset="-120"/>
               </a:rPr>
-              <a:t>7 rules, every score reproducible</a:t>
+              <a:t>7 rules</a:t>
             </a:r>
             <a:endParaRPr lang="en-US" sz="1300" dirty="0"/>
           </a:p>
@@ -4936,7 +5855,7 @@
                 <a:ea typeface="Calibri" pitchFamily="34" charset="-122"/>
                 <a:cs typeface="Calibri" pitchFamily="34" charset="-120"/>
               </a:rPr>
-              <a:t>by hand</a:t>
+              <a:t>every score reproducible by hand</a:t>
             </a:r>
             <a:endParaRPr lang="en-US" sz="1100" dirty="0"/>
           </a:p>
@@ -5053,7 +5972,7 @@
                 <a:ea typeface="Calibri" pitchFamily="34" charset="-122"/>
                 <a:cs typeface="Calibri" pitchFamily="34" charset="-120"/>
               </a:rPr>
-              <a:t>under 10 seconds</a:t>
+              <a:t>hash-chained custody</a:t>
             </a:r>
             <a:endParaRPr lang="en-US" sz="1300" dirty="0"/>
           </a:p>
@@ -5092,7 +6011,7 @@
                 <a:ea typeface="Calibri" pitchFamily="34" charset="-122"/>
                 <a:cs typeface="Calibri" pitchFamily="34" charset="-120"/>
               </a:rPr>
-              <a:t>live mainnet trace</a:t>
+              <a:t>tampering is detectable</a:t>
             </a:r>
             <a:endParaRPr lang="en-US" sz="1100" dirty="0"/>
           </a:p>
@@ -5209,7 +6128,7 @@
                 <a:ea typeface="Calibri" pitchFamily="34" charset="-122"/>
                 <a:cs typeface="Calibri" pitchFamily="34" charset="-120"/>
               </a:rPr>
-              <a:t>183</a:t>
+              <a:t>183 tests</a:t>
             </a:r>
             <a:endParaRPr lang="en-US" sz="1300" dirty="0"/>
           </a:p>
@@ -5248,7 +6167,7 @@
                 <a:ea typeface="Calibri" pitchFamily="34" charset="-122"/>
                 <a:cs typeface="Calibri" pitchFamily="34" charset="-120"/>
               </a:rPr>
-              <a:t>automated tests passing</a:t>
+              <a:t>19 endpoints, 4,582 lines</a:t>
             </a:r>
             <a:endParaRPr lang="en-US" sz="1100" dirty="0"/>
           </a:p>
@@ -5503,9 +6422,9 @@
 </p:sld>
 </file>
 
-<file path=ppt/slides/slide13.xml><?xml version="1.0" encoding="utf-8"?>
+<file path=ppt/slides/slide14.xml><?xml version="1.0" encoding="utf-8"?>
 <p:sld xmlns:a="http://schemas.openxmlformats.org/drawingml/2006/main" xmlns:r="http://schemas.openxmlformats.org/officeDocument/2006/relationships" xmlns:p="http://schemas.openxmlformats.org/presentationml/2006/main">
-  <p:cSld name="Slide 13">
+  <p:cSld name="Slide 14">
     <p:bg>
       <p:bgPr>
         <a:solidFill>
@@ -6153,9 +7072,9 @@
 </p:sld>
 </file>
 
-<file path=ppt/slides/slide14.xml><?xml version="1.0" encoding="utf-8"?>
+<file path=ppt/slides/slide15.xml><?xml version="1.0" encoding="utf-8"?>
 <p:sld xmlns:a="http://schemas.openxmlformats.org/drawingml/2006/main" xmlns:r="http://schemas.openxmlformats.org/officeDocument/2006/relationships" xmlns:p="http://schemas.openxmlformats.org/presentationml/2006/main">
-  <p:cSld name="Slide 14">
+  <p:cSld name="Slide 15">
     <p:bg>
       <p:bgPr>
         <a:solidFill>
@@ -6415,6 +7334,45 @@
                 <a:cs typeface="Calibri" pitchFamily="34" charset="-120"/>
               </a:rPr>
               <a:t>Demonstration build · synthetic case data · analytical leads, not findings of guilt</a:t>
+            </a:r>
+            <a:endParaRPr lang="en-US" sz="1100" dirty="0"/>
+          </a:p>
+        </p:txBody>
+      </p:sp>
+      <p:sp>
+        <p:nvSpPr>
+          <p:cNvPr id="9" name="Text 7"/>
+          <p:cNvSpPr txBox="1"/>
+          <p:nvPr/>
+        </p:nvSpPr>
+        <p:spPr>
+          <a:xfrm>
+            <a:off x="822960" y="5742432"/>
+            <a:ext cx="8229600" cy="274320"/>
+          </a:xfrm>
+          <a:prstGeom prst="rect">
+            <a:avLst/>
+          </a:prstGeom>
+          <a:noFill/>
+          <a:ln/>
+        </p:spPr>
+        <p:txBody>
+          <a:bodyPr wrap="square" lIns="0" tIns="0" rIns="0" bIns="0" rtlCol="0" anchor="ctr"/>
+          <a:lstStyle/>
+          <a:p>
+            <a:pPr indent="0" marL="0">
+              <a:buNone/>
+            </a:pPr>
+            <a:r>
+              <a:rPr lang="en-US" sz="1100" dirty="0">
+                <a:solidFill>
+                  <a:srgbClr val="8B6FD4"/>
+                </a:solidFill>
+                <a:latin typeface="Courier New" pitchFamily="34" charset="0"/>
+                <a:ea typeface="Courier New" pitchFamily="34" charset="-122"/>
+                <a:cs typeface="Courier New" pitchFamily="34" charset="-120"/>
+              </a:rPr>
+              <a:t>github.com/23f2001033/project-violet-milk</a:t>
             </a:r>
             <a:endParaRPr lang="en-US" sz="1100" dirty="0"/>
           </a:p>
@@ -8723,7 +9681,7 @@
                 <a:ea typeface="Calibri" pitchFamily="34" charset="-122"/>
                 <a:cs typeface="Calibri" pitchFamily="34" charset="-120"/>
               </a:rPr>
-              <a:t>Bank CSV + wallet data, hashed in the browser before upload</a:t>
+              <a:t>Bank or wallet CSV, hashed in the browser, parsed and merged into the case graph</a:t>
             </a:r>
             <a:endParaRPr lang="en-US" sz="1250" dirty="0"/>
           </a:p>
@@ -9391,7 +10349,7 @@
                 <a:ea typeface="Calibri" pitchFamily="34" charset="-122"/>
                 <a:cs typeface="Calibri" pitchFamily="34" charset="-120"/>
               </a:rPr>
-              <a:t>Timeline, risk breakdown, confirmed vs inferred</a:t>
+              <a:t>Timeline, risk breakdown, confirmed versus inferred</a:t>
             </a:r>
             <a:endParaRPr lang="en-US" sz="1250" dirty="0"/>
           </a:p>
@@ -13319,7 +14277,7 @@
                 <a:ea typeface="Calibri" pitchFamily="34" charset="-122"/>
                 <a:cs typeface="Calibri" pitchFamily="34" charset="-120"/>
               </a:rPr>
-              <a:t>ANCHORED EVIDENCE</a:t>
+              <a:t>CHAIN OF CUSTODY</a:t>
             </a:r>
             <a:endParaRPr lang="en-US" sz="1100" dirty="0"/>
           </a:p>
@@ -13358,7 +14316,7 @@
                 <a:ea typeface="Cambria" pitchFamily="34" charset="-122"/>
                 <a:cs typeface="Cambria" pitchFamily="34" charset="-120"/>
               </a:rPr>
-              <a:t>We publish the digest. The proof outlives the server.</a:t>
+              <a:t>An audit trail is only worth what its identity is worth</a:t>
             </a:r>
             <a:endParaRPr lang="en-US" sz="3400" dirty="0"/>
           </a:p>
@@ -13366,45 +14324,30 @@
       </p:sp>
       <p:sp>
         <p:nvSpPr>
-          <p:cNvPr id="4" name="Text 2"/>
-          <p:cNvSpPr txBox="1"/>
+          <p:cNvPr id="4" name="Shape 2"/>
+          <p:cNvSpPr/>
           <p:nvPr/>
         </p:nvSpPr>
         <p:spPr>
           <a:xfrm>
             <a:off x="566928" y="1572768"/>
-            <a:ext cx="5486400" cy="1005840"/>
-          </a:xfrm>
-          <a:prstGeom prst="rect">
-            <a:avLst/>
-          </a:prstGeom>
-          <a:noFill/>
-          <a:ln/>
-        </p:spPr>
-        <p:txBody>
-          <a:bodyPr wrap="square" lIns="0" tIns="0" rIns="0" bIns="0" rtlCol="0" anchor="ctr"/>
-          <a:lstStyle/>
-          <a:p>
-            <a:pPr indent="0" marL="0">
-              <a:lnSpc>
-                <a:spcPts val="2100"/>
-              </a:lnSpc>
-              <a:buNone/>
-            </a:pPr>
-            <a:r>
-              <a:rPr lang="en-US" sz="1400" dirty="0">
-                <a:solidFill>
-                  <a:srgbClr val="9A93AD"/>
-                </a:solidFill>
-                <a:latin typeface="Calibri" pitchFamily="34" charset="0"/>
-                <a:ea typeface="Calibri" pitchFamily="34" charset="-122"/>
-                <a:cs typeface="Calibri" pitchFamily="34" charset="-120"/>
-              </a:rPr>
-              <a:t>The SHA-256 of each ingested file is written to a public blockchain. That record sits outside this system — so if the machine is later compromised, rebuilt, or its database rewritten, the fact that the file existed in that exact form still stands.</a:t>
-            </a:r>
-            <a:endParaRPr lang="en-US" sz="1400" dirty="0"/>
-          </a:p>
-        </p:txBody>
+            <a:ext cx="5486400" cy="3749040"/>
+          </a:xfrm>
+          <a:prstGeom prst="roundRect">
+            <a:avLst>
+              <a:gd name="adj" fmla="val 732"/>
+            </a:avLst>
+          </a:prstGeom>
+          <a:solidFill>
+            <a:srgbClr val="1C1828"/>
+          </a:solidFill>
+          <a:ln w="12700">
+            <a:solidFill>
+              <a:srgbClr val="3A3350"/>
+            </a:solidFill>
+            <a:prstDash val="solid"/>
+          </a:ln>
+        </p:spPr>
       </p:sp>
       <p:sp>
         <p:nvSpPr>
@@ -13414,7 +14357,210 @@
         </p:nvSpPr>
         <p:spPr>
           <a:xfrm>
-            <a:off x="566928" y="2761488"/>
+            <a:off x="868680" y="1828800"/>
+            <a:ext cx="1097280" cy="274320"/>
+          </a:xfrm>
+          <a:prstGeom prst="roundRect">
+            <a:avLst>
+              <a:gd name="adj" fmla="val 16667"/>
+            </a:avLst>
+          </a:prstGeom>
+          <a:solidFill>
+            <a:srgbClr val="251F34"/>
+          </a:solidFill>
+          <a:ln w="12700">
+            <a:solidFill>
+              <a:srgbClr val="E5484D"/>
+            </a:solidFill>
+            <a:prstDash val="solid"/>
+          </a:ln>
+        </p:spPr>
+      </p:sp>
+      <p:sp>
+        <p:nvSpPr>
+          <p:cNvPr id="6" name="Text 4"/>
+          <p:cNvSpPr txBox="1"/>
+          <p:nvPr/>
+        </p:nvSpPr>
+        <p:spPr>
+          <a:xfrm>
+            <a:off x="868680" y="1828800"/>
+            <a:ext cx="1097280" cy="274320"/>
+          </a:xfrm>
+          <a:prstGeom prst="rect">
+            <a:avLst/>
+          </a:prstGeom>
+          <a:noFill/>
+          <a:ln/>
+        </p:spPr>
+        <p:txBody>
+          <a:bodyPr wrap="square" lIns="0" tIns="0" rIns="0" bIns="0" rtlCol="0" anchor="ctr"/>
+          <a:lstStyle/>
+          <a:p>
+            <a:pPr algn="ctr" indent="0" marL="0">
+              <a:buNone/>
+            </a:pPr>
+            <a:r>
+              <a:rPr lang="en-US" sz="1000" b="1" dirty="0">
+                <a:solidFill>
+                  <a:srgbClr val="E5484D"/>
+                </a:solidFill>
+                <a:latin typeface="Calibri" pitchFamily="34" charset="0"/>
+                <a:ea typeface="Calibri" pitchFamily="34" charset="-122"/>
+                <a:cs typeface="Calibri" pitchFamily="34" charset="-120"/>
+              </a:rPr>
+              <a:t>BEFORE</a:t>
+            </a:r>
+            <a:endParaRPr lang="en-US" sz="1000" dirty="0"/>
+          </a:p>
+        </p:txBody>
+      </p:sp>
+      <p:sp>
+        <p:nvSpPr>
+          <p:cNvPr id="7" name="Text 5"/>
+          <p:cNvSpPr txBox="1"/>
+          <p:nvPr/>
+        </p:nvSpPr>
+        <p:spPr>
+          <a:xfrm>
+            <a:off x="868680" y="2267712"/>
+            <a:ext cx="4937760" cy="310896"/>
+          </a:xfrm>
+          <a:prstGeom prst="rect">
+            <a:avLst/>
+          </a:prstGeom>
+          <a:noFill/>
+          <a:ln/>
+        </p:spPr>
+        <p:txBody>
+          <a:bodyPr wrap="square" lIns="0" tIns="0" rIns="0" bIns="0" rtlCol="0" anchor="ctr"/>
+          <a:lstStyle/>
+          <a:p>
+            <a:pPr indent="0" marL="0">
+              <a:buNone/>
+            </a:pPr>
+            <a:r>
+              <a:rPr lang="en-US" sz="1400" b="1" dirty="0">
+                <a:solidFill>
+                  <a:srgbClr val="EDEAF3"/>
+                </a:solidFill>
+                <a:latin typeface="Calibri" pitchFamily="34" charset="0"/>
+                <a:ea typeface="Calibri" pitchFamily="34" charset="-122"/>
+                <a:cs typeface="Calibri" pitchFamily="34" charset="-120"/>
+              </a:rPr>
+              <a:t>The officer name was a form field.</a:t>
+            </a:r>
+            <a:endParaRPr lang="en-US" sz="1400" dirty="0"/>
+          </a:p>
+        </p:txBody>
+      </p:sp>
+      <p:sp>
+        <p:nvSpPr>
+          <p:cNvPr id="8" name="Text 6"/>
+          <p:cNvSpPr txBox="1"/>
+          <p:nvPr/>
+        </p:nvSpPr>
+        <p:spPr>
+          <a:xfrm>
+            <a:off x="868680" y="2670048"/>
+            <a:ext cx="4937760" cy="2194560"/>
+          </a:xfrm>
+          <a:prstGeom prst="rect">
+            <a:avLst/>
+          </a:prstGeom>
+          <a:noFill/>
+          <a:ln/>
+        </p:spPr>
+        <p:txBody>
+          <a:bodyPr wrap="square" lIns="0" tIns="0" rIns="0" bIns="0" rtlCol="0" anchor="ctr"/>
+          <a:lstStyle/>
+          <a:p>
+            <a:pPr indent="0" marL="0">
+              <a:lnSpc>
+                <a:spcPts val="1800"/>
+              </a:lnSpc>
+              <a:buNone/>
+            </a:pPr>
+            <a:r>
+              <a:rPr lang="en-US" sz="1250" dirty="0">
+                <a:solidFill>
+                  <a:srgbClr val="9A93AD"/>
+                </a:solidFill>
+                <a:latin typeface="Calibri" pitchFamily="34" charset="0"/>
+                <a:ea typeface="Calibri" pitchFamily="34" charset="-122"/>
+                <a:cs typeface="Calibri" pitchFamily="34" charset="-120"/>
+              </a:rPr>
+              <a:t>Anyone on the network could file evidence as any officer, and the log sat in a database file that any client could edit without trace.</a:t>
+            </a:r>
+            <a:endParaRPr lang="en-US" sz="1250" dirty="0"/>
+          </a:p>
+          <a:p>
+            <a:pPr indent="0" marL="0">
+              <a:lnSpc>
+                <a:spcPts val="1800"/>
+              </a:lnSpc>
+              <a:buNone/>
+            </a:pPr>
+            <a:endParaRPr lang="en-US" sz="1250" dirty="0"/>
+          </a:p>
+          <a:p>
+            <a:pPr indent="0" marL="0">
+              <a:lnSpc>
+                <a:spcPts val="1800"/>
+              </a:lnSpc>
+              <a:buNone/>
+            </a:pPr>
+            <a:r>
+              <a:rPr lang="en-US" sz="1250" dirty="0">
+                <a:solidFill>
+                  <a:srgbClr val="9A93AD"/>
+                </a:solidFill>
+                <a:latin typeface="Calibri" pitchFamily="34" charset="0"/>
+                <a:ea typeface="Calibri" pitchFamily="34" charset="-122"/>
+                <a:cs typeface="Calibri" pitchFamily="34" charset="-120"/>
+              </a:rPr>
+              <a:t>A custody record that the caller supplies, in a table the caller can rewrite, is not a custody record. It is the legal spine of the dossier, so that mattered more than any feature.</a:t>
+            </a:r>
+            <a:endParaRPr lang="en-US" sz="1250" dirty="0"/>
+          </a:p>
+        </p:txBody>
+      </p:sp>
+      <p:sp>
+        <p:nvSpPr>
+          <p:cNvPr id="9" name="Shape 7"/>
+          <p:cNvSpPr/>
+          <p:nvPr/>
+        </p:nvSpPr>
+        <p:spPr>
+          <a:xfrm>
+            <a:off x="6355080" y="1572768"/>
+            <a:ext cx="5276088" cy="3749040"/>
+          </a:xfrm>
+          <a:prstGeom prst="roundRect">
+            <a:avLst>
+              <a:gd name="adj" fmla="val 732"/>
+            </a:avLst>
+          </a:prstGeom>
+          <a:solidFill>
+            <a:srgbClr val="1C1828"/>
+          </a:solidFill>
+          <a:ln w="12700">
+            <a:solidFill>
+              <a:srgbClr val="3A3350"/>
+            </a:solidFill>
+            <a:prstDash val="solid"/>
+          </a:ln>
+        </p:spPr>
+      </p:sp>
+      <p:sp>
+        <p:nvSpPr>
+          <p:cNvPr id="10" name="Shape 8"/>
+          <p:cNvSpPr/>
+          <p:nvPr/>
+        </p:nvSpPr>
+        <p:spPr>
+          <a:xfrm>
+            <a:off x="6656832" y="1828800"/>
             <a:ext cx="1097280" cy="274320"/>
           </a:xfrm>
           <a:prstGeom prst="roundRect">
@@ -13435,13 +14581,13 @@
       </p:sp>
       <p:sp>
         <p:nvSpPr>
-          <p:cNvPr id="6" name="Text 4"/>
-          <p:cNvSpPr txBox="1"/>
-          <p:nvPr/>
-        </p:nvSpPr>
-        <p:spPr>
-          <a:xfrm>
-            <a:off x="566928" y="2761488"/>
+          <p:cNvPr id="11" name="Text 9"/>
+          <p:cNvSpPr txBox="1"/>
+          <p:nvPr/>
+        </p:nvSpPr>
+        <p:spPr>
+          <a:xfrm>
+            <a:off x="6656832" y="1828800"/>
             <a:ext cx="1097280" cy="274320"/>
           </a:xfrm>
           <a:prstGeom prst="rect">
@@ -13466,7 +14612,7 @@
                 <a:ea typeface="Calibri" pitchFamily="34" charset="-122"/>
                 <a:cs typeface="Calibri" pitchFamily="34" charset="-120"/>
               </a:rPr>
-              <a:t>PROVES</a:t>
+              <a:t>NOW</a:t>
             </a:r>
             <a:endParaRPr lang="en-US" sz="1000" dirty="0"/>
           </a:p>
@@ -13474,14 +14620,14 @@
       </p:sp>
       <p:sp>
         <p:nvSpPr>
-          <p:cNvPr id="7" name="Text 5"/>
-          <p:cNvSpPr txBox="1"/>
-          <p:nvPr/>
-        </p:nvSpPr>
-        <p:spPr>
-          <a:xfrm>
-            <a:off x="566928" y="3145536"/>
-            <a:ext cx="5486400" cy="1097280"/>
+          <p:cNvPr id="12" name="Text 10"/>
+          <p:cNvSpPr txBox="1"/>
+          <p:nvPr/>
+        </p:nvSpPr>
+        <p:spPr>
+          <a:xfrm>
+            <a:off x="6656832" y="2304288"/>
+            <a:ext cx="4663440" cy="1828800"/>
           </a:xfrm>
           <a:prstGeom prst="rect">
             <a:avLst/>
@@ -13495,13 +14641,13 @@
           <a:p>
             <a:pPr marL="342900" indent="-342900">
               <a:spcAft>
-                <a:spcPts val="600"/>
+                <a:spcPts val="700"/>
               </a:spcAft>
               <a:buSzPct val="100000"/>
               <a:buChar char="•"/>
             </a:pPr>
             <a:r>
-              <a:rPr lang="en-US" sz="1300" dirty="0">
+              <a:rPr lang="en-US" sz="1250" dirty="0">
                 <a:solidFill>
                   <a:srgbClr val="EDEAF3"/>
                 </a:solidFill>
@@ -13509,20 +14655,20 @@
                 <a:ea typeface="Calibri" pitchFamily="34" charset="-122"/>
                 <a:cs typeface="Calibri" pitchFamily="34" charset="-120"/>
               </a:rPr>
-              <a:t>the digest existed at or before that block</a:t>
-            </a:r>
-            <a:endParaRPr lang="en-US" sz="1300" dirty="0"/>
+              <a:t>Every action requires a signed-in officer</a:t>
+            </a:r>
+            <a:endParaRPr lang="en-US" sz="1250" dirty="0"/>
           </a:p>
           <a:p>
             <a:pPr marL="342900" indent="-342900">
               <a:spcAft>
-                <a:spcPts val="600"/>
+                <a:spcPts val="700"/>
               </a:spcAft>
               <a:buSzPct val="100000"/>
               <a:buChar char="•"/>
             </a:pPr>
             <a:r>
-              <a:rPr lang="en-US" sz="1300" dirty="0">
+              <a:rPr lang="en-US" sz="1250" dirty="0">
                 <a:solidFill>
                   <a:srgbClr val="EDEAF3"/>
                 </a:solidFill>
@@ -13530,20 +14676,20 @@
                 <a:ea typeface="Calibri" pitchFamily="34" charset="-122"/>
                 <a:cs typeface="Calibri" pitchFamily="34" charset="-120"/>
               </a:rPr>
-              <a:t>the record cannot afterwards be revised</a:t>
-            </a:r>
-            <a:endParaRPr lang="en-US" sz="1300" dirty="0"/>
+              <a:t>Identity comes from the session, never the request body</a:t>
+            </a:r>
+            <a:endParaRPr lang="en-US" sz="1250" dirty="0"/>
           </a:p>
           <a:p>
             <a:pPr marL="342900" indent="-342900">
               <a:spcAft>
-                <a:spcPts val="600"/>
+                <a:spcPts val="700"/>
               </a:spcAft>
               <a:buSzPct val="100000"/>
               <a:buChar char="•"/>
             </a:pPr>
             <a:r>
-              <a:rPr lang="en-US" sz="1300" dirty="0">
+              <a:rPr lang="en-US" sz="1250" dirty="0">
                 <a:solidFill>
                   <a:srgbClr val="EDEAF3"/>
                 </a:solidFill>
@@ -13551,195 +14697,59 @@
                 <a:ea typeface="Calibri" pitchFamily="34" charset="-122"/>
                 <a:cs typeface="Calibri" pitchFamily="34" charset="-120"/>
               </a:rPr>
-              <a:t>a substituted document no longer matches</a:t>
-            </a:r>
-            <a:endParaRPr lang="en-US" sz="1300" dirty="0"/>
-          </a:p>
-        </p:txBody>
-      </p:sp>
-      <p:sp>
-        <p:nvSpPr>
-          <p:cNvPr id="8" name="Shape 6"/>
-          <p:cNvSpPr/>
-          <p:nvPr/>
-        </p:nvSpPr>
-        <p:spPr>
-          <a:xfrm>
-            <a:off x="566928" y="4315968"/>
-            <a:ext cx="1828800" cy="274320"/>
-          </a:xfrm>
-          <a:prstGeom prst="roundRect">
-            <a:avLst>
-              <a:gd name="adj" fmla="val 16667"/>
-            </a:avLst>
-          </a:prstGeom>
-          <a:solidFill>
-            <a:srgbClr val="251F34"/>
-          </a:solidFill>
-          <a:ln w="12700">
-            <a:solidFill>
-              <a:srgbClr val="E5484D"/>
-            </a:solidFill>
-            <a:prstDash val="solid"/>
-          </a:ln>
-        </p:spPr>
-      </p:sp>
-      <p:sp>
-        <p:nvSpPr>
-          <p:cNvPr id="9" name="Text 7"/>
-          <p:cNvSpPr txBox="1"/>
-          <p:nvPr/>
-        </p:nvSpPr>
-        <p:spPr>
-          <a:xfrm>
-            <a:off x="566928" y="4315968"/>
-            <a:ext cx="1828800" cy="274320"/>
-          </a:xfrm>
-          <a:prstGeom prst="rect">
-            <a:avLst/>
-          </a:prstGeom>
-          <a:noFill/>
-          <a:ln/>
-        </p:spPr>
-        <p:txBody>
-          <a:bodyPr wrap="square" lIns="0" tIns="0" rIns="0" bIns="0" rtlCol="0" anchor="ctr"/>
-          <a:lstStyle/>
-          <a:p>
-            <a:pPr algn="ctr" indent="0" marL="0">
-              <a:buNone/>
-            </a:pPr>
-            <a:r>
-              <a:rPr lang="en-US" sz="1000" b="1" dirty="0">
-                <a:solidFill>
-                  <a:srgbClr val="E5484D"/>
-                </a:solidFill>
-                <a:latin typeface="Calibri" pitchFamily="34" charset="0"/>
-                <a:ea typeface="Calibri" pitchFamily="34" charset="-122"/>
-                <a:cs typeface="Calibri" pitchFamily="34" charset="-120"/>
-              </a:rPr>
-              <a:t>DOES NOT PROVE</a:t>
-            </a:r>
-            <a:endParaRPr lang="en-US" sz="1000" dirty="0"/>
-          </a:p>
-        </p:txBody>
-      </p:sp>
-      <p:sp>
-        <p:nvSpPr>
-          <p:cNvPr id="10" name="Text 8"/>
-          <p:cNvSpPr txBox="1"/>
-          <p:nvPr/>
-        </p:nvSpPr>
-        <p:spPr>
-          <a:xfrm>
-            <a:off x="566928" y="4700016"/>
-            <a:ext cx="5486400" cy="822960"/>
-          </a:xfrm>
-          <a:prstGeom prst="rect">
-            <a:avLst/>
-          </a:prstGeom>
-          <a:noFill/>
-          <a:ln/>
-        </p:spPr>
-        <p:txBody>
-          <a:bodyPr wrap="square" lIns="0" tIns="0" rIns="0" bIns="0" rtlCol="0" anchor="ctr"/>
-          <a:lstStyle/>
+              <a:t>Each entry commits to the one before it</a:t>
+            </a:r>
+            <a:endParaRPr lang="en-US" sz="1250" dirty="0"/>
+          </a:p>
           <a:p>
             <a:pPr marL="342900" indent="-342900">
               <a:spcAft>
-                <a:spcPts val="600"/>
+                <a:spcPts val="700"/>
               </a:spcAft>
               <a:buSzPct val="100000"/>
               <a:buChar char="•"/>
             </a:pPr>
             <a:r>
-              <a:rPr lang="en-US" sz="1300" dirty="0">
-                <a:solidFill>
-                  <a:srgbClr val="9A93AD"/>
-                </a:solidFill>
-                <a:latin typeface="Calibri" pitchFamily="34" charset="0"/>
-                <a:ea typeface="Calibri" pitchFamily="34" charset="-122"/>
-                <a:cs typeface="Calibri" pitchFamily="34" charset="-120"/>
-              </a:rPr>
-              <a:t>who created the document — anyone may anchor any digest</a:t>
-            </a:r>
-            <a:endParaRPr lang="en-US" sz="1300" dirty="0"/>
-          </a:p>
-          <a:p>
-            <a:pPr marL="342900" indent="-342900">
-              <a:spcAft>
-                <a:spcPts val="600"/>
-              </a:spcAft>
-              <a:buSzPct val="100000"/>
-              <a:buChar char="•"/>
-            </a:pPr>
-            <a:r>
-              <a:rPr lang="en-US" sz="1300" dirty="0">
-                <a:solidFill>
-                  <a:srgbClr val="9A93AD"/>
-                </a:solidFill>
-                <a:latin typeface="Calibri" pitchFamily="34" charset="0"/>
-                <a:ea typeface="Calibri" pitchFamily="34" charset="-122"/>
-                <a:cs typeface="Calibri" pitchFamily="34" charset="-120"/>
-              </a:rPr>
-              <a:t>that the document is tamper-PROOF — only tamper-EVIDENT</a:t>
-            </a:r>
-            <a:endParaRPr lang="en-US" sz="1300" dirty="0"/>
-          </a:p>
-        </p:txBody>
-      </p:sp>
-      <p:sp>
-        <p:nvSpPr>
-          <p:cNvPr id="11" name="Shape 9"/>
-          <p:cNvSpPr/>
-          <p:nvPr/>
-        </p:nvSpPr>
-        <p:spPr>
-          <a:xfrm>
-            <a:off x="6355080" y="1572768"/>
-            <a:ext cx="5276088" cy="3977640"/>
-          </a:xfrm>
-          <a:prstGeom prst="roundRect">
-            <a:avLst>
-              <a:gd name="adj" fmla="val 690"/>
-            </a:avLst>
-          </a:prstGeom>
-          <a:solidFill>
-            <a:srgbClr val="1C1828"/>
-          </a:solidFill>
-          <a:ln w="12700">
-            <a:solidFill>
-              <a:srgbClr val="3A3350"/>
-            </a:solidFill>
-            <a:prstDash val="solid"/>
-          </a:ln>
-        </p:spPr>
-      </p:sp>
-      <p:sp>
-        <p:nvSpPr>
-          <p:cNvPr id="12" name="Text 10"/>
-          <p:cNvSpPr txBox="1"/>
-          <p:nvPr/>
-        </p:nvSpPr>
-        <p:spPr>
-          <a:xfrm>
-            <a:off x="6656832" y="1828800"/>
-            <a:ext cx="4663440" cy="274320"/>
-          </a:xfrm>
-          <a:prstGeom prst="rect">
-            <a:avLst/>
-          </a:prstGeom>
-          <a:noFill/>
-          <a:ln/>
-        </p:spPr>
-        <p:txBody>
-          <a:bodyPr wrap="square" lIns="0" tIns="0" rIns="0" bIns="0" rtlCol="0" anchor="ctr"/>
-          <a:lstStyle/>
-          <a:p>
-            <a:pPr indent="0" marL="0">
-              <a:buNone/>
-            </a:pPr>
-            <a:r>
-              <a:rPr lang="en-US" sz="1200" dirty="0">
+              <a:rPr lang="en-US" sz="1250" dirty="0">
+                <a:solidFill>
+                  <a:srgbClr val="EDEAF3"/>
+                </a:solidFill>
+                <a:latin typeface="Calibri" pitchFamily="34" charset="0"/>
+                <a:ea typeface="Calibri" pitchFamily="34" charset="-122"/>
+                <a:cs typeface="Calibri" pitchFamily="34" charset="-120"/>
+              </a:rPr>
+              <a:t>Editing, reordering or deleting any row breaks every later link</a:t>
+            </a:r>
+            <a:endParaRPr lang="en-US" sz="1250" dirty="0"/>
+          </a:p>
+        </p:txBody>
+      </p:sp>
+      <p:sp>
+        <p:nvSpPr>
+          <p:cNvPr id="13" name="Text 11"/>
+          <p:cNvSpPr txBox="1"/>
+          <p:nvPr/>
+        </p:nvSpPr>
+        <p:spPr>
+          <a:xfrm>
+            <a:off x="6656832" y="4059936"/>
+            <a:ext cx="4663440" cy="457200"/>
+          </a:xfrm>
+          <a:prstGeom prst="rect">
+            <a:avLst/>
+          </a:prstGeom>
+          <a:noFill/>
+          <a:ln/>
+        </p:spPr>
+        <p:txBody>
+          <a:bodyPr wrap="square" lIns="0" tIns="0" rIns="0" bIns="0" rtlCol="0" anchor="ctr"/>
+          <a:lstStyle/>
+          <a:p>
+            <a:pPr indent="0" marL="0">
+              <a:buNone/>
+            </a:pPr>
+            <a:r>
+              <a:rPr lang="en-US" sz="900" dirty="0">
                 <a:solidFill>
                   <a:srgbClr val="8B6FD4"/>
                 </a:solidFill>
@@ -13747,22 +14757,22 @@
                 <a:ea typeface="Courier New" pitchFamily="34" charset="-122"/>
                 <a:cs typeface="Courier New" pitchFamily="34" charset="-120"/>
               </a:rPr>
-              <a:t>EvidenceAnchor.sol</a:t>
-            </a:r>
-            <a:endParaRPr lang="en-US" sz="1200" dirty="0"/>
-          </a:p>
-        </p:txBody>
-      </p:sp>
-      <p:sp>
-        <p:nvSpPr>
-          <p:cNvPr id="13" name="Text 11"/>
-          <p:cNvSpPr txBox="1"/>
-          <p:nvPr/>
-        </p:nvSpPr>
-        <p:spPr>
-          <a:xfrm>
-            <a:off x="6656832" y="2176272"/>
-            <a:ext cx="4663440" cy="1920240"/>
+              <a:t>entry_hash = SHA256(prev_hash | id | time | user | action | target)</a:t>
+            </a:r>
+            <a:endParaRPr lang="en-US" sz="900" dirty="0"/>
+          </a:p>
+        </p:txBody>
+      </p:sp>
+      <p:sp>
+        <p:nvSpPr>
+          <p:cNvPr id="14" name="Text 12"/>
+          <p:cNvSpPr txBox="1"/>
+          <p:nvPr/>
+        </p:nvSpPr>
+        <p:spPr>
+          <a:xfrm>
+            <a:off x="6656832" y="4535424"/>
+            <a:ext cx="4663440" cy="640080"/>
           </a:xfrm>
           <a:prstGeom prst="rect">
             <a:avLst/>
@@ -13776,278 +14786,28 @@
           <a:p>
             <a:pPr indent="0" marL="0">
               <a:lnSpc>
-                <a:spcPts val="1300"/>
+                <a:spcPts val="1500"/>
               </a:lnSpc>
               <a:buNone/>
             </a:pPr>
             <a:r>
-              <a:rPr lang="en-US" sz="950" dirty="0">
-                <a:solidFill>
-                  <a:srgbClr val="9A93AD"/>
-                </a:solidFill>
-                <a:latin typeface="Courier New" pitchFamily="34" charset="0"/>
-                <a:ea typeface="Courier New" pitchFamily="34" charset="-122"/>
-                <a:cs typeface="Courier New" pitchFamily="34" charset="-120"/>
-              </a:rPr>
-              <a:t>function anchor(bytes32 digest) external {</a:t>
-            </a:r>
-            <a:endParaRPr lang="en-US" sz="950" dirty="0"/>
-          </a:p>
-          <a:p>
-            <a:pPr indent="0" marL="0">
-              <a:lnSpc>
-                <a:spcPts val="1300"/>
-              </a:lnSpc>
-              <a:buNone/>
-            </a:pPr>
-            <a:r>
-              <a:rPr lang="en-US" sz="950" dirty="0">
-                <a:solidFill>
-                  <a:srgbClr val="9A93AD"/>
-                </a:solidFill>
-                <a:latin typeface="Courier New" pitchFamily="34" charset="0"/>
-                <a:ea typeface="Courier New" pitchFamily="34" charset="-122"/>
-                <a:cs typeface="Courier New" pitchFamily="34" charset="-120"/>
-              </a:rPr>
-              <a:t>    if (_anchors[digest].blockNumber != 0)</a:t>
-            </a:r>
-            <a:endParaRPr lang="en-US" sz="950" dirty="0"/>
-          </a:p>
-          <a:p>
-            <a:pPr indent="0" marL="0">
-              <a:lnSpc>
-                <a:spcPts val="1300"/>
-              </a:lnSpc>
-              <a:buNone/>
-            </a:pPr>
-            <a:r>
-              <a:rPr lang="en-US" sz="950" dirty="0">
-                <a:solidFill>
-                  <a:srgbClr val="9A93AD"/>
-                </a:solidFill>
-                <a:latin typeface="Courier New" pitchFamily="34" charset="0"/>
-                <a:ea typeface="Courier New" pitchFamily="34" charset="-122"/>
-                <a:cs typeface="Courier New" pitchFamily="34" charset="-120"/>
-              </a:rPr>
-              <a:t>        revert AlreadyAnchored(...);</a:t>
-            </a:r>
-            <a:endParaRPr lang="en-US" sz="950" dirty="0"/>
-          </a:p>
-          <a:p>
-            <a:pPr indent="0" marL="0">
-              <a:lnSpc>
-                <a:spcPts val="1300"/>
-              </a:lnSpc>
-              <a:buNone/>
-            </a:pPr>
-            <a:endParaRPr lang="en-US" sz="950" dirty="0"/>
-          </a:p>
-          <a:p>
-            <a:pPr indent="0" marL="0">
-              <a:lnSpc>
-                <a:spcPts val="1300"/>
-              </a:lnSpc>
-              <a:buNone/>
-            </a:pPr>
-            <a:r>
-              <a:rPr lang="en-US" sz="950" dirty="0">
-                <a:solidFill>
-                  <a:srgbClr val="9A93AD"/>
-                </a:solidFill>
-                <a:latin typeface="Courier New" pitchFamily="34" charset="0"/>
-                <a:ea typeface="Courier New" pitchFamily="34" charset="-122"/>
-                <a:cs typeface="Courier New" pitchFamily="34" charset="-120"/>
-              </a:rPr>
-              <a:t>    _anchors[digest] = Anchor({</a:t>
-            </a:r>
-            <a:endParaRPr lang="en-US" sz="950" dirty="0"/>
-          </a:p>
-          <a:p>
-            <a:pPr indent="0" marL="0">
-              <a:lnSpc>
-                <a:spcPts val="1300"/>
-              </a:lnSpc>
-              <a:buNone/>
-            </a:pPr>
-            <a:r>
-              <a:rPr lang="en-US" sz="950" dirty="0">
-                <a:solidFill>
-                  <a:srgbClr val="9A93AD"/>
-                </a:solidFill>
-                <a:latin typeface="Courier New" pitchFamily="34" charset="0"/>
-                <a:ea typeface="Courier New" pitchFamily="34" charset="-122"/>
-                <a:cs typeface="Courier New" pitchFamily="34" charset="-120"/>
-              </a:rPr>
-              <a:t>        blockTime:   uint64(block.timestamp),</a:t>
-            </a:r>
-            <a:endParaRPr lang="en-US" sz="950" dirty="0"/>
-          </a:p>
-          <a:p>
-            <a:pPr indent="0" marL="0">
-              <a:lnSpc>
-                <a:spcPts val="1300"/>
-              </a:lnSpc>
-              <a:buNone/>
-            </a:pPr>
-            <a:r>
-              <a:rPr lang="en-US" sz="950" dirty="0">
-                <a:solidFill>
-                  <a:srgbClr val="9A93AD"/>
-                </a:solidFill>
-                <a:latin typeface="Courier New" pitchFamily="34" charset="0"/>
-                <a:ea typeface="Courier New" pitchFamily="34" charset="-122"/>
-                <a:cs typeface="Courier New" pitchFamily="34" charset="-120"/>
-              </a:rPr>
-              <a:t>        blockNumber: uint64(block.number),</a:t>
-            </a:r>
-            <a:endParaRPr lang="en-US" sz="950" dirty="0"/>
-          </a:p>
-          <a:p>
-            <a:pPr indent="0" marL="0">
-              <a:lnSpc>
-                <a:spcPts val="1300"/>
-              </a:lnSpc>
-              <a:buNone/>
-            </a:pPr>
-            <a:r>
-              <a:rPr lang="en-US" sz="950" dirty="0">
-                <a:solidFill>
-                  <a:srgbClr val="9A93AD"/>
-                </a:solidFill>
-                <a:latin typeface="Courier New" pitchFamily="34" charset="0"/>
-                <a:ea typeface="Courier New" pitchFamily="34" charset="-122"/>
-                <a:cs typeface="Courier New" pitchFamily="34" charset="-120"/>
-              </a:rPr>
-              <a:t>        anchoredBy:  msg.sender</a:t>
-            </a:r>
-            <a:endParaRPr lang="en-US" sz="950" dirty="0"/>
-          </a:p>
-          <a:p>
-            <a:pPr indent="0" marL="0">
-              <a:lnSpc>
-                <a:spcPts val="1300"/>
-              </a:lnSpc>
-              <a:buNone/>
-            </a:pPr>
-            <a:r>
-              <a:rPr lang="en-US" sz="950" dirty="0">
-                <a:solidFill>
-                  <a:srgbClr val="9A93AD"/>
-                </a:solidFill>
-                <a:latin typeface="Courier New" pitchFamily="34" charset="0"/>
-                <a:ea typeface="Courier New" pitchFamily="34" charset="-122"/>
-                <a:cs typeface="Courier New" pitchFamily="34" charset="-120"/>
-              </a:rPr>
-              <a:t>    });</a:t>
-            </a:r>
-            <a:endParaRPr lang="en-US" sz="950" dirty="0"/>
-          </a:p>
-          <a:p>
-            <a:pPr indent="0" marL="0">
-              <a:lnSpc>
-                <a:spcPts val="1300"/>
-              </a:lnSpc>
-              <a:buNone/>
-            </a:pPr>
-            <a:r>
-              <a:rPr lang="en-US" sz="950" dirty="0">
-                <a:solidFill>
-                  <a:srgbClr val="9A93AD"/>
-                </a:solidFill>
-                <a:latin typeface="Courier New" pitchFamily="34" charset="0"/>
-                <a:ea typeface="Courier New" pitchFamily="34" charset="-122"/>
-                <a:cs typeface="Courier New" pitchFamily="34" charset="-120"/>
-              </a:rPr>
-              <a:t>}</a:t>
-            </a:r>
-            <a:endParaRPr lang="en-US" sz="950" dirty="0"/>
-          </a:p>
-        </p:txBody>
-      </p:sp>
-      <p:sp>
-        <p:nvSpPr>
-          <p:cNvPr id="14" name="Text 12"/>
-          <p:cNvSpPr txBox="1"/>
-          <p:nvPr/>
-        </p:nvSpPr>
-        <p:spPr>
-          <a:xfrm>
-            <a:off x="6656832" y="4178808"/>
-            <a:ext cx="4663440" cy="256032"/>
-          </a:xfrm>
-          <a:prstGeom prst="rect">
-            <a:avLst/>
-          </a:prstGeom>
-          <a:noFill/>
-          <a:ln/>
-        </p:spPr>
-        <p:txBody>
-          <a:bodyPr wrap="square" lIns="0" tIns="0" rIns="0" bIns="0" rtlCol="0" anchor="ctr"/>
-          <a:lstStyle/>
-          <a:p>
-            <a:pPr indent="0" marL="0">
-              <a:buNone/>
-            </a:pPr>
-            <a:r>
-              <a:rPr lang="en-US" sz="1200" b="1" dirty="0">
-                <a:solidFill>
-                  <a:srgbClr val="EDEAF3"/>
-                </a:solidFill>
-                <a:latin typeface="Calibri" pitchFamily="34" charset="0"/>
-                <a:ea typeface="Calibri" pitchFamily="34" charset="-122"/>
-                <a:cs typeface="Calibri" pitchFamily="34" charset="-120"/>
-              </a:rPr>
-              <a:t>First write wins.</a:t>
-            </a:r>
-            <a:endParaRPr lang="en-US" sz="1200" dirty="0"/>
+              <a:rPr lang="en-US" sz="1100" i="1" dirty="0">
+                <a:solidFill>
+                  <a:srgbClr val="5F5A70"/>
+                </a:solidFill>
+                <a:latin typeface="Calibri" pitchFamily="34" charset="0"/>
+                <a:ea typeface="Calibri" pitchFamily="34" charset="-122"/>
+                <a:cs typeface="Calibri" pitchFamily="34" charset="-120"/>
+              </a:rPr>
+              <a:t>This makes tampering DETECTABLE, not impossible. Only an append-only store or external notarisation prevents it — which is what the anchoring does.</a:t>
+            </a:r>
+            <a:endParaRPr lang="en-US" sz="1100" dirty="0"/>
           </a:p>
         </p:txBody>
       </p:sp>
       <p:sp>
         <p:nvSpPr>
           <p:cNvPr id="15" name="Text 13"/>
-          <p:cNvSpPr txBox="1"/>
-          <p:nvPr/>
-        </p:nvSpPr>
-        <p:spPr>
-          <a:xfrm>
-            <a:off x="6656832" y="4462272"/>
-            <a:ext cx="4663440" cy="914400"/>
-          </a:xfrm>
-          <a:prstGeom prst="rect">
-            <a:avLst/>
-          </a:prstGeom>
-          <a:noFill/>
-          <a:ln/>
-        </p:spPr>
-        <p:txBody>
-          <a:bodyPr wrap="square" lIns="0" tIns="0" rIns="0" bIns="0" rtlCol="0" anchor="ctr"/>
-          <a:lstStyle/>
-          <a:p>
-            <a:pPr indent="0" marL="0">
-              <a:lnSpc>
-                <a:spcPts val="1600"/>
-              </a:lnSpc>
-              <a:buNone/>
-            </a:pPr>
-            <a:r>
-              <a:rPr lang="en-US" sz="1150" dirty="0">
-                <a:solidFill>
-                  <a:srgbClr val="5F5A70"/>
-                </a:solidFill>
-                <a:latin typeface="Calibri" pitchFamily="34" charset="0"/>
-                <a:ea typeface="Calibri" pitchFamily="34" charset="-122"/>
-                <a:cs typeface="Calibri" pitchFamily="34" charset="-120"/>
-              </a:rPr>
-              <a:t>Re-anchoring reverts rather than overwriting. The earliest record is the evidentially meaningful one, and silently replacing it would let a later party claim an earlier document’s timestamp.</a:t>
-            </a:r>
-            <a:endParaRPr lang="en-US" sz="1150" dirty="0"/>
-          </a:p>
-        </p:txBody>
-      </p:sp>
-      <p:sp>
-        <p:nvSpPr>
-          <p:cNvPr id="16" name="Text 14"/>
           <p:cNvSpPr txBox="1"/>
           <p:nvPr/>
         </p:nvSpPr>
@@ -14078,7 +14838,7 @@
                 <a:ea typeface="Calibri" pitchFamily="34" charset="-122"/>
                 <a:cs typeface="Calibri" pitchFamily="34" charset="-120"/>
               </a:rPr>
-              <a:t>Verification is read-only and needs no credentials — anyone auditing the dossier can check the anchor without access to our systems.</a:t>
+              <a:t>A test files evidence as ‘IO_IMPOSTER’ and asserts the log still names the officer who was actually signed in.</a:t>
             </a:r>
             <a:endParaRPr lang="en-US" sz="1000" dirty="0"/>
           </a:p>

</xml_diff>